<commit_message>
docs(assets): update architecture diagram to 3-node DB layout (#37)
The diagram still showed two DB VMs after #30 moved the replica set to
three electable members. Add vm-db-az3 in Availability Zone 3 and use
the same image on the learners portal Day 0 page.

Closes #37

Co-authored-by: Copilot <223556219+Copilot@users.noreply.github.com>
</commit_message>
<xml_diff>
--- a/assets/Architecture.pptx
+++ b/assets/Architecture.pptx
@@ -128,7 +128,7 @@
           <inkml:channelProperty channel="F" name="resolution" value="0" units="1/dev"/>
         </inkml:channelProperties>
       </inkml:inkSource>
-      <inkml:timestamp xml:id="ts0" timeString="2026-01-13T04:15:24.116"/>
+      <inkml:timestamp xml:id="ts0" timeString="2026-01-13T04:15:27.592"/>
     </inkml:context>
     <inkml:brush xml:id="br0">
       <inkml:brushProperty name="width" value="0.035" units="cm"/>
@@ -136,7 +136,7 @@
       <inkml:brushProperty name="color" value="#E71224"/>
     </inkml:brush>
   </inkml:definitions>
-  <inkml:trace contextRef="#ctx0" brushRef="#br0">1 1 24575,'50'0'0,"1"0"0,11-1 0,3 2 0,7 6 0,2 5 0,15 8 0,-1 8-633,-19 6 1,0 5 632,13 4 0,5 5-832,-12-1 0,3 4 0,1-1 832,-2-3 0,1-2 0,6 5 0,-12-5 0,7 4 0,1 2 0,0 0 0,-6-5 0,-4-2 0,-4-3 0,0 0 0,2 1 0,13 6 0,4 2 0,-1-1 0,-8-4-75,-7-3 0,-6-3 1,2-1 74,3-3 0,2-2 0,-2 2 0,-5 3 0,-1 2 0,2-1 0,5-2 0,1 0 0,-4-1 0,6 9 0,-1 2-183,-5-5 1,4 4 0,-8-4 182,-13-6 0,-1 1 0,5 3 0,5 3 0,-8-5 517,26 24-517,-21-16 0,-3 1 2105,8 11-2105,-20-19 0,1 3 615,-6-1 1,-2 0-616,26 26 339,-20-19 1,-3-1-340,7 10 0,16 21 0,-30-39 0,7 7 0,-13-14 0,0 2 0,-11-10 0,5 10 0,-13-21 0,8 16 0,-6-13 0,-1 3 0,0-5 0,2 3 0,-5-6 0,4 9 0,-6-9 0,0 2 0,0-8 0,0 0 0</inkml:trace>
+  <inkml:trace contextRef="#ctx0" brushRef="#br0">0 151 24575,'49'19'0,"-24"-10"0,29 14 0,-23-7 0,-3-3 0,6 5 0,-11-7 0,-4 1 0,4 0 0,-10-4 0,12 3 0,-18-6 0,7-2 0,-9 4 0,-1-1 0,5-1 0,1 0 0,7-5 0,-5 3 0,1 1 0,-2 0 0,-2 0 0,6-4 0,-12 5 0,6-10 0,-9-4 0,0-34 0,0 6 0,9-29 0,-5 31 0,11-13 0,-7 17 0,0 6 0,-3 8 0,-3 6 0,-2 8 0,0-10 0,0 10 0,0-4 0</inkml:trace>
 </inkml:ink>
 </file>
 
@@ -156,7 +156,7 @@
           <inkml:channelProperty channel="F" name="resolution" value="0" units="1/dev"/>
         </inkml:channelProperties>
       </inkml:inkSource>
-      <inkml:timestamp xml:id="ts0" timeString="2026-01-13T04:18:56.643"/>
+      <inkml:timestamp xml:id="ts0" timeString="2026-10-08T07:11:45.007"/>
     </inkml:context>
     <inkml:brush xml:id="br0">
       <inkml:brushProperty name="width" value="0.035" units="cm"/>
@@ -164,7 +164,7 @@
       <inkml:brushProperty name="color" value="#E71224"/>
     </inkml:brush>
   </inkml:definitions>
-  <inkml:trace contextRef="#ctx0" brushRef="#br0">2135 0 24575,'0'71'0,"0"0"0,0-19 0,0 0 0,0 10 0,0-2 0,0 28 0,0-5 0,0-21 0,0 3 0,0-6 0,0 2 0,-1 20 0,2 5-323,5 14 1,2-2 322,-2-21 0,3 1 0,2-7 0,3 3 0,0-7 0,-2-9 0,1-2 0,5 17 0,-1 7 0,-1 18 0,-3-3 0,-4-40 0,0-1-58,1 11 1,0 7 0,0-9 57,8 34 0,-6-32 0,1 2 0,0-6 0,-2 0 0,-4-3 0,-2-1 0,6 35 319,-10-39 1,-2 0-320,1 30 89,0-29 0,0 0-89,0 36 0,0-7 0,0 8 0,0-38 0,0 26 0,0-22 0,0-16 0,0 22 0,0-23 0,0 9 0,0-10 0,0-7 0,0 1 0,0-5 0,0-2 0,0-9 0,-8 13 0,5-16 0,-8 24 0,6-19 0,-3 8 0,-4 5 0,-1-14 0,-7 13 0,-7-13 0,-14 7 0,-27 11 0,10 0 0,13-12 0,-2-2 0,-33 12 0,30-11 0,-2-2 0,-3-3 0,-1-1 0,2 4 0,1 0 0,-2-5 0,1-3 0,-40 15 0,19-8 0,0-1 0,-18 4 0,11-2 0,-2-1 0,32-8 0,1 0 0,-11 0 0,1 1 0,-33 8 0,2 1 0,47-11 0,-25 9 0,46-16 0,-39 17 0,24-16 0,-43 7 0,25-9 0,-18-3 0,25 2 0,5 1 0,15 0 0,9-1 0,7-2 0,2 0 0,4-5 0,3 0 0,5-1 0,0 3 0</inkml:trace>
+  <inkml:trace contextRef="#ctx0" brushRef="#br0">1281 1 24575,'0'20'0,"0"69"0,0-9 0,0-14 0,0 11 0,0-7 0,0-12 0,0 0 0,0 29 0,0-3 0,0-1 0,1-26 0,-2 1 0,-5 24 0,-5-18 0,-2 0 0,-13 32 0,3-22 0,-1 0 0,6-22 0,2-2 0,-2 14 0,1-3 0,-4 0 0,9-20 0,-1-2 0,-2-7 0,-14 29 0,-7 11 0,5-13 0,-3 4-218,3 0 1,-2 5 0,1-3 217,-13 11 0,4-4 0,10-11 0,3-5 0,-14 14 0,22-30 0,14-28 0,-12 18 0,-11 15 652,-13 28-652,12-35 0,-3 2 0,2 13 0,0-2 0,-17 3 0,13 5 0,28-48 0,0-1 0,2-1 0,-20 18 0,-1 8 0,-8 4 0,-2 4 0,-13 17 0,-13 15 0,36-45 0,7-10 0,12-12 0,2-3 0,2-2 0,3-3 0</inkml:trace>
 </inkml:ink>
 </file>
 
@@ -184,7 +184,7 @@
           <inkml:channelProperty channel="F" name="resolution" value="0" units="1/dev"/>
         </inkml:channelProperties>
       </inkml:inkSource>
-      <inkml:timestamp xml:id="ts0" timeString="2026-01-13T04:18:58.400"/>
+      <inkml:timestamp xml:id="ts0" timeString="2026-10-08T07:11:46.509"/>
     </inkml:context>
     <inkml:brush xml:id="br0">
       <inkml:brushProperty name="width" value="0.035" units="cm"/>
@@ -192,39 +192,11 @@
       <inkml:brushProperty name="color" value="#E71224"/>
     </inkml:brush>
   </inkml:definitions>
-  <inkml:trace contextRef="#ctx0" brushRef="#br0">512 0 24575,'-53'0'0,"9"5"0,-9 20 0,15-4 0,-42 20 0,33-15 0,-8 3 0,14-2 0,9-2 0,8-6 0,9 1 0,7-12 0,-5 4 0,11-5 0,-4 4 0,6-4 0,0 4 0,10-7 0,10 8 0,59 3 0,5 4 0,-32-7 0,2 0 0,2-1 0,-2 1 0,14 5 0,5 2 0,-30-3 0,-21-4 0,0 1 0,-10-8 0,-2 0 0,-4-5 0,-4 0 0</inkml:trace>
+  <inkml:trace contextRef="#ctx0" brushRef="#br0">0 1 24575,'0'47'0,"0"-4"0,0 9 0,0 2 0,0 4 0,0 19 0,0-51 0,0-9 0,0-8 0,0-5 0,0 1 0,1-2 0,7-6 0,-2-2 0,11-4 0,4-3 0,5 1 0,20-6 0,10-2 0,10 6 0,6 0 0,-19 2 0,1 0 0,22-1 0,-4 2 0,-4 0 0,-24 3 0,-29 5 0,-8 1 0,-6 1 0</inkml:trace>
 </inkml:ink>
 </file>
 
 <file path=ppt/ink/ink2.xml><?xml version="1.0" encoding="utf-8"?>
-<inkml:ink xmlns:inkml="http://www.w3.org/2003/InkML">
-  <inkml:definitions>
-    <inkml:context xml:id="ctx0">
-      <inkml:inkSource xml:id="inkSrc0">
-        <inkml:traceFormat>
-          <inkml:channel name="X" type="integer" min="-2.14748E9" max="2.14748E9" units="cm"/>
-          <inkml:channel name="Y" type="integer" min="-2.14748E9" max="2.14748E9" units="cm"/>
-          <inkml:channel name="F" type="integer" max="32767" units="dev"/>
-        </inkml:traceFormat>
-        <inkml:channelProperties>
-          <inkml:channelProperty channel="X" name="resolution" value="1000" units="1/cm"/>
-          <inkml:channelProperty channel="Y" name="resolution" value="1000" units="1/cm"/>
-          <inkml:channelProperty channel="F" name="resolution" value="0" units="1/dev"/>
-        </inkml:channelProperties>
-      </inkml:inkSource>
-      <inkml:timestamp xml:id="ts0" timeString="2026-01-13T04:15:27.592"/>
-    </inkml:context>
-    <inkml:brush xml:id="br0">
-      <inkml:brushProperty name="width" value="0.035" units="cm"/>
-      <inkml:brushProperty name="height" value="0.035" units="cm"/>
-      <inkml:brushProperty name="color" value="#E71224"/>
-    </inkml:brush>
-  </inkml:definitions>
-  <inkml:trace contextRef="#ctx0" brushRef="#br0">0 151 24575,'49'19'0,"-24"-10"0,29 14 0,-23-7 0,-3-3 0,6 5 0,-11-7 0,-4 1 0,4 0 0,-10-4 0,12 3 0,-18-6 0,7-2 0,-9 4 0,-1-1 0,5-1 0,1 0 0,7-5 0,-5 3 0,1 1 0,-2 0 0,-2 0 0,6-4 0,-12 5 0,6-10 0,-9-4 0,0-34 0,0 6 0,9-29 0,-5 31 0,11-13 0,-7 17 0,0 6 0,-3 8 0,-3 6 0,-2 8 0,0-10 0,0 10 0,0-4 0</inkml:trace>
-</inkml:ink>
-</file>
-
-<file path=ppt/ink/ink3.xml><?xml version="1.0" encoding="utf-8"?>
 <inkml:ink xmlns:inkml="http://www.w3.org/2003/InkML">
   <inkml:definitions>
     <inkml:context xml:id="ctx0">
@@ -252,7 +224,7 @@
 </inkml:ink>
 </file>
 
-<file path=ppt/ink/ink4.xml><?xml version="1.0" encoding="utf-8"?>
+<file path=ppt/ink/ink3.xml><?xml version="1.0" encoding="utf-8"?>
 <inkml:ink xmlns:inkml="http://www.w3.org/2003/InkML">
   <inkml:definitions>
     <inkml:context xml:id="ctx0">
@@ -280,7 +252,7 @@
 </inkml:ink>
 </file>
 
-<file path=ppt/ink/ink5.xml><?xml version="1.0" encoding="utf-8"?>
+<file path=ppt/ink/ink4.xml><?xml version="1.0" encoding="utf-8"?>
 <inkml:ink xmlns:inkml="http://www.w3.org/2003/InkML">
   <inkml:definitions>
     <inkml:context xml:id="ctx0">
@@ -308,6 +280,34 @@
 </inkml:ink>
 </file>
 
+<file path=ppt/ink/ink5.xml><?xml version="1.0" encoding="utf-8"?>
+<inkml:ink xmlns:inkml="http://www.w3.org/2003/InkML">
+  <inkml:definitions>
+    <inkml:context xml:id="ctx0">
+      <inkml:inkSource xml:id="inkSrc0">
+        <inkml:traceFormat>
+          <inkml:channel name="X" type="integer" min="-2.14748E9" max="2.14748E9" units="cm"/>
+          <inkml:channel name="Y" type="integer" min="-2.14748E9" max="2.14748E9" units="cm"/>
+          <inkml:channel name="F" type="integer" max="32767" units="dev"/>
+        </inkml:traceFormat>
+        <inkml:channelProperties>
+          <inkml:channelProperty channel="X" name="resolution" value="1000" units="1/cm"/>
+          <inkml:channelProperty channel="Y" name="resolution" value="1000" units="1/cm"/>
+          <inkml:channelProperty channel="F" name="resolution" value="0" units="1/dev"/>
+        </inkml:channelProperties>
+      </inkml:inkSource>
+      <inkml:timestamp xml:id="ts0" timeString="2026-10-08T07:08:09.409"/>
+    </inkml:context>
+    <inkml:brush xml:id="br0">
+      <inkml:brushProperty name="width" value="0.035" units="cm"/>
+      <inkml:brushProperty name="height" value="0.035" units="cm"/>
+      <inkml:brushProperty name="color" value="#E71224"/>
+    </inkml:brush>
+  </inkml:definitions>
+  <inkml:trace contextRef="#ctx0" brushRef="#br0">0 0 24575,'23'85'0,"-1"-1"0,1 1 0,-1-1 0,0-4 0,-1 0 0,0-1 0,-2 0 0,-1-5 0,-1 0 0,-1 0 0,-1 0 0,2 4 0,-1 2 0,0-2 0,-1-4 0,1 6 0,-2-5 0,1-1 0,-2-1 0,0-1 0,-2-14 0,1 1 0,2 15 0,-1-11 0,-1-12 0,-4-21 0,0-8 0,-4-12 0,0 2 0,-2-2 0,5 13 0,-3-5 0,5 10 0,0 3 0,1 9 0,13 34 0,0 15 0,2 7 0,-5-23 0,0 0 0,-2-4 0,1 4 0,-4-11 0,4 11 0,-6-30 0,-7-33 0,0 0 0,4 3 0,-2-4 0,-1-1 0,1 5 0,1-1 0,-1 3 0,2-3 0,-3-4 0,0 1 0,-2-1 0,-3 1 0,0 0 0,-1 0 0,5 2 0,4 2 0,1-2 0,-1 1 0,-5-8 0,-1 3 0,-2-5 0,-1 2 0,-1 1 0,0 0 0,3 5 0,2-2 0,2 2 0,-1-2 0,-3-1 0,-2 0 0,-1 0 0,0-1 0,0-2 0,0-1 0</inkml:trace>
+</inkml:ink>
+</file>
+
 <file path=ppt/ink/ink6.xml><?xml version="1.0" encoding="utf-8"?>
 <inkml:ink xmlns:inkml="http://www.w3.org/2003/InkML">
   <inkml:definitions>
@@ -324,7 +324,7 @@
           <inkml:channelProperty channel="F" name="resolution" value="0" units="1/dev"/>
         </inkml:channelProperties>
       </inkml:inkSource>
-      <inkml:timestamp xml:id="ts0" timeString="2026-01-13T04:18:45.022"/>
+      <inkml:timestamp xml:id="ts0" timeString="2026-10-08T07:11:36.292"/>
     </inkml:context>
     <inkml:brush xml:id="br0">
       <inkml:brushProperty name="width" value="0.035" units="cm"/>
@@ -332,7 +332,7 @@
       <inkml:brushProperty name="color" value="#E71224"/>
     </inkml:brush>
   </inkml:definitions>
-  <inkml:trace contextRef="#ctx0" brushRef="#br0">3596 0 24575,'-46'0'0,"8"0"0,-17 4 0,16 0 0,5 7 0,-3 9 0,-19-4 0,-8 21 0,17-15 0,-1 1 0,-29 24 0,26-17 0,2 0 0,-2 2 0,-33 17 0,36-18 0,-35 16 0,22-10 0,-10-4 0,11 0 0,4-6 0,1-2 0,-1 5 0,0-1 0,2 0 0,2 2 0,-19 12 0,23-20 0,-1 2 0,4 1 0,-1 2 0,-11 5 0,-1 0 0,7 0 0,2 0 0,7-3 0,1 2 0,-15 10 0,3-2 0,-1 6 0,-18 20 0,0 1 0,10-16 0,-5 13 0,-2 2 0,-4 0 0,7-9 0,-2 3 0,16-16 0,1-1 0,-11 7 0,0-3 0,17-16 0,2-2 0,-35 28 0,14-16 0,-4 8 0,17-19 0,4 4 0,17-15 0,-11 27 0,12-17 0,-15 21 0,13-20 0,6 0 0,-3 8 0,14-15 0,-5 6 0,11-24 0,5 3 0,0-6 0,3 3 0,0-4 0</inkml:trace>
+  <inkml:trace contextRef="#ctx0" brushRef="#br0">7697 1 24575,'-36'5'0,"-32"16"0,-18 10 0,1 3 0,-8 4 0,-2 1 0,16-7 0,-2 0 0,-1 1 0,-1 2-1005,9-4 0,-2 1 1,0 1-1,1 0 1,3-2 1004,-3 1 0,3-1 0,0-1 0,-2 2 0,-14 6 0,-3 0 0,-1 1 0,0 0 0,14-6 0,-1-1 0,0 1 0,0 0 0,2-2 0,-14 6 0,1-2 0,1 0 0,2-1 0,8-3 0,2-1 0,2 0 0,2-3 459,-9 1 1,4-3-1,-3 1-459,-11 3 0,-4 1 0,1-1 0,3 1 0,0-1 0,-1 0 0,17-7 0,-1 0 0,-2-1 0,1 1 0,-6 2 0,-1 0 0,2 0 0,5-2-74,3 0 1,5-3 0,-3 2 73,-21 6 0,-3 1 0,9-3 0,5-1 0,4-3-294,-17 1 1,0-3 293,15-4 0,-1-2 0,-14 0 0,2-1 0,23-4 0,1 0 0,-17 3 0,0 0 0,17-2 0,1 0 1210,-13 2 1,2-1-1211,22-2 0,2 0 58,-19 3 1,1 1-59,19-2 0,-1 0 0,-24 4 0,-3 1 0,13 4 0,-3 2 0,1-3 0,-6 1 0,3 0 0,-12 9 0,2 0 397,17-8 0,-1 0 0,9-2-397,-22 9 723,20-7-723,38-11 0,-3 1 0,6 0 0,-3-2 0,2-1 0,6-2 0,8-2 0,3-1 0</inkml:trace>
 </inkml:ink>
 </file>
 
@@ -352,7 +352,7 @@
           <inkml:channelProperty channel="F" name="resolution" value="0" units="1/dev"/>
         </inkml:channelProperties>
       </inkml:inkSource>
-      <inkml:timestamp xml:id="ts0" timeString="2026-01-13T04:18:46.970"/>
+      <inkml:timestamp xml:id="ts0" timeString="2026-10-08T07:11:37.576"/>
     </inkml:context>
     <inkml:brush xml:id="br0">
       <inkml:brushProperty name="width" value="0.035" units="cm"/>
@@ -360,7 +360,7 @@
       <inkml:brushProperty name="color" value="#E71224"/>
     </inkml:brush>
   </inkml:definitions>
-  <inkml:trace contextRef="#ctx0" brushRef="#br0">1 1 24575,'0'74'0,"0"-4"0,0 5 0,0-11 0,0-23 0,0 4 0,0-32 0,0 9 0,0-18 0,0 7 0,0-9 0,0 10 0,0-8 0,0 7 0,0 0 0,0-3 0,0 7 0,0-9 0,0 3 0,3-5 0,7-6 0,21-9 0,1-2 0,14-15 0,-16 12 0,-7-4 0,-9 11 0,1-1 0,-3 6 0,-1-2 0,-5 0 0,-6-2 0,6-1 0,2-4 0,1 7 0,4-5 0,-1 8 0,1-1 0,-3 4 0,-5 0 0</inkml:trace>
+  <inkml:trace contextRef="#ctx0" brushRef="#br0">412 1 24575,'-25'15'0,"-21"21"0,-4 5 0,-6 4 0,1 3 0,5-3 0,27-19 0,7 3 0,9-18 0,5 1 0,1-6 0,-9 7 0,-1 1 0,-9 5 0,8-6 0,-3 7 0,9-13 0,0 6 0,15-12 0,12-1 0,7-5 0,15 4 0,2-4 0,20 5 0,-22 0 0,1 0 0,-32 0 0,-3 0 0,-4 0 0,-2 0 0,-3 0 0</inkml:trace>
 </inkml:ink>
 </file>
 
@@ -380,7 +380,7 @@
           <inkml:channelProperty channel="F" name="resolution" value="0" units="1/dev"/>
         </inkml:channelProperties>
       </inkml:inkSource>
-      <inkml:timestamp xml:id="ts0" timeString="2026-01-13T04:18:49.278"/>
+      <inkml:timestamp xml:id="ts0" timeString="2026-10-08T07:11:41.017"/>
     </inkml:context>
     <inkml:brush xml:id="br0">
       <inkml:brushProperty name="width" value="0.035" units="cm"/>
@@ -388,7 +388,7 @@
       <inkml:brushProperty name="color" value="#E71224"/>
     </inkml:brush>
   </inkml:definitions>
-  <inkml:trace contextRef="#ctx0" brushRef="#br0">2287 0 24575,'0'55'0,"0"-12"0,0 33 0,0 11 0,0-26 0,0 4-431,0 16 0,0 11 0,0-9 431,0-6 0,0-3 0,0 18 0,0-2 137,0-32 1,0-1-138,0 19 0,0 1 124,0-18 1,0-2-125,0 8 0,0 0 0,1-6 0,-2-2 0,-6-6 0,0-1 326,5 12 1,-1 0-327,-18 32 58,17-37 0,1 1-58,-13 34 0,8-24 0,-9 26 0,4-29 0,0 21 0,-6-11 0,2-7 0,-10-5 0,2 10 0,-7-13 0,2 8 0,2-16 0,-15 26 0,6-20 0,8-15 0,-2-1 0,-10 17 0,-21 17 0,24-27 0,-6 5 0,0-1 0,10-9 0,-12 10 0,1-4 0,15-20 0,-5 8 0,-3 2 0,-13 8 0,-7 19 0,10-16 0,1-3 0,9-5 0,-14-4 0,5-3 0,-6 14 0,-22 7 0,25-12 0,9-18 0,-3 2 0,-3 4 0,2 0 0,-19 8 0,14-4 0,4-2 0,7-6 0,-19 11 0,13-5 0,3 0 0,8-10 0,-2 8 0,5-12 0,-6 9 0,2-8 0,0-1 0,3-5 0,3 0 0,3-1 0,12-6 0,-2-2 0,14 0 0,-8-3 0,7 3 0,-7-5 0,7-2 0,-1 0 0</inkml:trace>
+  <inkml:trace contextRef="#ctx0" brushRef="#br0">4738 1 24575,'0'45'0,"0"14"0,0-10 0,0 4 0,0-2 0,0 3 0,0 13 0,0 5 0,0 16 0,0 0 0,0-21 0,0-1 0,-1 15 0,-2-4 0,-4 18 0,-1-23 0,-3 1 0,-1-18 0,1 1 0,-2 22 0,1-2 0,-8 15 0,10-37 0,2-3 0,-2 8 0,-2 1 0,7-38 0,3 21 0,1-8 0,1 50 0,-11-16 0,8-13 0,0-1 0,-10 9 0,7 4 0,4-52 0,-1 14 0,-2-1 0,2 53 0,-6-8 0,5 1 0,1 2 0,-5 12 0,5-30 0,0-7 0,0-19 0,-1 1 0,-2-15 0,-5 25 0,-4 4 0,-13 31 0,8-31 0,-9 12 0,17-46 0,-21 15 0,-5-5 0,-31 14 0,-15-3 0,-4-4 0,-7-1 0,18-9 0,-2-2-182,7-1 0,-5 0 1,5-1 181,-1-1 0,0-2 0,5-2 0,-5-1 0,3 0 0,-8 3 0,0 1 0,7-2 0,-4-1 0,3 0 0,-8 3 0,1 0 0,11-3 0,-3 0 0,3 0 0,-11 2 0,1 0 0,-19 1 0,3-1 0,28-6 0,2 0 0,-13-1 0,1 0 0,19-1 0,2-1 0,-7-1 0,3-1 0,-10 4 0,17-3 0,-3 0 0,4 2 0,-2 1 0,-26 2 0,-3-1 0,14 0 0,-3 2 0,4 0 0,-5 2 0,5-1 0,0-2 0,2 0 272,-14 6 1,2-1-273,-11-1 0,26-5 0,0-2 0,-32 2 0,34-3 0,3-2 0,-6-1 0,24 1 0,14 0 0,12-1 0,10-4 0,18-47 0,-10 35 0,12-34 0</inkml:trace>
 </inkml:ink>
 </file>
 
@@ -408,7 +408,7 @@
           <inkml:channelProperty channel="F" name="resolution" value="0" units="1/dev"/>
         </inkml:channelProperties>
       </inkml:inkSource>
-      <inkml:timestamp xml:id="ts0" timeString="2026-01-13T04:18:53.912"/>
+      <inkml:timestamp xml:id="ts0" timeString="2026-10-08T07:11:42.693"/>
     </inkml:context>
     <inkml:brush xml:id="br0">
       <inkml:brushProperty name="width" value="0.035" units="cm"/>
@@ -416,7 +416,7 @@
       <inkml:brushProperty name="color" value="#E71224"/>
     </inkml:brush>
   </inkml:definitions>
-  <inkml:trace contextRef="#ctx0" brushRef="#br0">269 1 24575,'0'3'0,"-1"1"0,-26 74 0,13-44 0,-28 56 0,21-46 0,-11 13 0,-3 21 0,-5-1 0,9 3 0,10-29 0,17-6 0,4-29 0,0 7 0,0-10 0,0 2 0,0 0 0,0-6 0,0 0 0,0-2 0,11-3 0,21-5 0,-7-3 0,58-29 0,-31 17 0,21-15 0,-24 18 0,-1 1 0,10-9 0,23-6 0,-35 11 0,-26 5 0,1 10 0,-9-3 0,3 4 0,-1 0 0,1 0 0,-6 0 0,5 0 0,-8-5 0,7 3 0,-8-3 0,0 4 0</inkml:trace>
+  <inkml:trace contextRef="#ctx0" brushRef="#br0">418 0 24575,'-14'0'0,"-58"16"0,19 9 0,-38 8 0,50-2 0,9-8 0,-9 2 0,19-11 0,-12 11 0,26-20 0,0 6 0,7-8 0,1 1 0,0 0 0,6-3 0,8 2 0,13-3 0,44 0 0,-10 0 0,7 0 0,-31 2 0,-17 4 0,-10-2 0,5 5 0,-11-7 0,0 4 0,5-2 0,-6 1 0,6 1 0,-2-2 0,0 2 0,2 1 0,-5-3 0,-1-1 0</inkml:trace>
 </inkml:ink>
 </file>
 
@@ -567,7 +567,7 @@
           <a:p>
             <a:fld id="{F0CB0818-5DF7-A940-86F4-FFB7C80D4BAA}" type="datetimeFigureOut">
               <a:rPr kumimoji="1" lang="ja-JP" altLang="en-US" smtClean="0"/>
-              <a:t>2026/2/9</a:t>
+              <a:t>2026/10/8</a:t>
             </a:fld>
             <a:endParaRPr kumimoji="1" lang="ja-JP" altLang="en-US"/>
           </a:p>
@@ -797,7 +797,7 @@
           <a:p>
             <a:fld id="{F0CB0818-5DF7-A940-86F4-FFB7C80D4BAA}" type="datetimeFigureOut">
               <a:rPr kumimoji="1" lang="ja-JP" altLang="en-US" smtClean="0"/>
-              <a:t>2026/2/9</a:t>
+              <a:t>2026/10/8</a:t>
             </a:fld>
             <a:endParaRPr kumimoji="1" lang="ja-JP" altLang="en-US"/>
           </a:p>
@@ -1037,7 +1037,7 @@
           <a:p>
             <a:fld id="{F0CB0818-5DF7-A940-86F4-FFB7C80D4BAA}" type="datetimeFigureOut">
               <a:rPr kumimoji="1" lang="ja-JP" altLang="en-US" smtClean="0"/>
-              <a:t>2026/2/9</a:t>
+              <a:t>2026/10/8</a:t>
             </a:fld>
             <a:endParaRPr kumimoji="1" lang="ja-JP" altLang="en-US"/>
           </a:p>
@@ -1267,7 +1267,7 @@
           <a:p>
             <a:fld id="{F0CB0818-5DF7-A940-86F4-FFB7C80D4BAA}" type="datetimeFigureOut">
               <a:rPr kumimoji="1" lang="ja-JP" altLang="en-US" smtClean="0"/>
-              <a:t>2026/2/9</a:t>
+              <a:t>2026/10/8</a:t>
             </a:fld>
             <a:endParaRPr kumimoji="1" lang="ja-JP" altLang="en-US"/>
           </a:p>
@@ -1542,7 +1542,7 @@
           <a:p>
             <a:fld id="{F0CB0818-5DF7-A940-86F4-FFB7C80D4BAA}" type="datetimeFigureOut">
               <a:rPr kumimoji="1" lang="ja-JP" altLang="en-US" smtClean="0"/>
-              <a:t>2026/2/9</a:t>
+              <a:t>2026/10/8</a:t>
             </a:fld>
             <a:endParaRPr kumimoji="1" lang="ja-JP" altLang="en-US"/>
           </a:p>
@@ -1871,7 +1871,7 @@
           <a:p>
             <a:fld id="{F0CB0818-5DF7-A940-86F4-FFB7C80D4BAA}" type="datetimeFigureOut">
               <a:rPr kumimoji="1" lang="ja-JP" altLang="en-US" smtClean="0"/>
-              <a:t>2026/2/9</a:t>
+              <a:t>2026/10/8</a:t>
             </a:fld>
             <a:endParaRPr kumimoji="1" lang="ja-JP" altLang="en-US"/>
           </a:p>
@@ -2347,7 +2347,7 @@
           <a:p>
             <a:fld id="{F0CB0818-5DF7-A940-86F4-FFB7C80D4BAA}" type="datetimeFigureOut">
               <a:rPr kumimoji="1" lang="ja-JP" altLang="en-US" smtClean="0"/>
-              <a:t>2026/2/9</a:t>
+              <a:t>2026/10/8</a:t>
             </a:fld>
             <a:endParaRPr kumimoji="1" lang="ja-JP" altLang="en-US"/>
           </a:p>
@@ -2488,7 +2488,7 @@
           <a:p>
             <a:fld id="{F0CB0818-5DF7-A940-86F4-FFB7C80D4BAA}" type="datetimeFigureOut">
               <a:rPr kumimoji="1" lang="ja-JP" altLang="en-US" smtClean="0"/>
-              <a:t>2026/2/9</a:t>
+              <a:t>2026/10/8</a:t>
             </a:fld>
             <a:endParaRPr kumimoji="1" lang="ja-JP" altLang="en-US"/>
           </a:p>
@@ -2601,7 +2601,7 @@
           <a:p>
             <a:fld id="{F0CB0818-5DF7-A940-86F4-FFB7C80D4BAA}" type="datetimeFigureOut">
               <a:rPr kumimoji="1" lang="ja-JP" altLang="en-US" smtClean="0"/>
-              <a:t>2026/2/9</a:t>
+              <a:t>2026/10/8</a:t>
             </a:fld>
             <a:endParaRPr kumimoji="1" lang="ja-JP" altLang="en-US"/>
           </a:p>
@@ -2944,7 +2944,7 @@
           <a:p>
             <a:fld id="{F0CB0818-5DF7-A940-86F4-FFB7C80D4BAA}" type="datetimeFigureOut">
               <a:rPr kumimoji="1" lang="ja-JP" altLang="en-US" smtClean="0"/>
-              <a:t>2026/2/9</a:t>
+              <a:t>2026/10/8</a:t>
             </a:fld>
             <a:endParaRPr kumimoji="1" lang="ja-JP" altLang="en-US"/>
           </a:p>
@@ -3232,7 +3232,7 @@
           <a:p>
             <a:fld id="{F0CB0818-5DF7-A940-86F4-FFB7C80D4BAA}" type="datetimeFigureOut">
               <a:rPr kumimoji="1" lang="ja-JP" altLang="en-US" smtClean="0"/>
-              <a:t>2026/2/9</a:t>
+              <a:t>2026/10/8</a:t>
             </a:fld>
             <a:endParaRPr kumimoji="1" lang="ja-JP" altLang="en-US"/>
           </a:p>
@@ -3505,7 +3505,7 @@
           <a:p>
             <a:fld id="{F0CB0818-5DF7-A940-86F4-FFB7C80D4BAA}" type="datetimeFigureOut">
               <a:rPr kumimoji="1" lang="ja-JP" altLang="en-US" smtClean="0"/>
-              <a:t>2026/2/9</a:t>
+              <a:t>2026/10/8</a:t>
             </a:fld>
             <a:endParaRPr kumimoji="1" lang="ja-JP" altLang="en-US"/>
           </a:p>
@@ -3936,7 +3936,7 @@
         </p:nvSpPr>
         <p:spPr>
           <a:xfrm>
-            <a:off x="3767852" y="1981860"/>
+            <a:off x="2184378" y="1981860"/>
             <a:ext cx="1482764" cy="4768676"/>
           </a:xfrm>
           <a:prstGeom prst="rect">
@@ -3994,7 +3994,7 @@
         </p:nvSpPr>
         <p:spPr>
           <a:xfrm>
-            <a:off x="5443805" y="1981860"/>
+            <a:off x="3860331" y="1981860"/>
             <a:ext cx="1482764" cy="4768676"/>
           </a:xfrm>
           <a:prstGeom prst="rect">
@@ -4052,8 +4052,8 @@
         </p:nvSpPr>
         <p:spPr>
           <a:xfrm>
-            <a:off x="3228177" y="1874778"/>
-            <a:ext cx="6629805" cy="4335331"/>
+            <a:off x="1538869" y="1874778"/>
+            <a:ext cx="8319114" cy="4335331"/>
           </a:xfrm>
           <a:prstGeom prst="rect">
             <a:avLst/>
@@ -4151,8 +4151,8 @@
         </p:nvSpPr>
         <p:spPr>
           <a:xfrm>
-            <a:off x="3389543" y="2357854"/>
-            <a:ext cx="3797449" cy="3701648"/>
+            <a:off x="1728439" y="2357854"/>
+            <a:ext cx="5458553" cy="3701648"/>
           </a:xfrm>
           <a:prstGeom prst="roundRect">
             <a:avLst>
@@ -4208,7 +4208,7 @@
         </p:nvSpPr>
         <p:spPr>
           <a:xfrm>
-            <a:off x="3808680" y="2452580"/>
+            <a:off x="2202904" y="2452580"/>
             <a:ext cx="1312396" cy="261610"/>
           </a:xfrm>
           <a:prstGeom prst="rect">
@@ -4251,10 +4251,10 @@
           <p:nvPr/>
         </p:nvPicPr>
         <p:blipFill>
-          <a:blip r:embed="rId2">
+          <a:blip>
             <a:extLst>
               <a:ext uri="{96DAC541-7B7A-43D3-8B79-37D633B846F1}">
-                <asvg:svgBlip xmlns:asvg="http://schemas.microsoft.com/office/drawing/2016/SVG/main" r:embed="rId3"/>
+                <asvg:svgBlip xmlns:asvg="http://schemas.microsoft.com/office/drawing/2016/SVG/main" r:embed="rId2"/>
               </a:ext>
             </a:extLst>
           </a:blip>
@@ -4264,7 +4264,7 @@
         </p:blipFill>
         <p:spPr>
           <a:xfrm>
-            <a:off x="3484980" y="2414180"/>
+            <a:off x="1879204" y="2414180"/>
             <a:ext cx="323700" cy="323700"/>
           </a:xfrm>
           <a:prstGeom prst="rect">
@@ -4287,10 +4287,10 @@
           <p:nvPr/>
         </p:nvPicPr>
         <p:blipFill>
-          <a:blip r:embed="rId4">
+          <a:blip>
             <a:extLst>
               <a:ext uri="{96DAC541-7B7A-43D3-8B79-37D633B846F1}">
-                <asvg:svgBlip xmlns:asvg="http://schemas.microsoft.com/office/drawing/2016/SVG/main" r:embed="rId5"/>
+                <asvg:svgBlip xmlns:asvg="http://schemas.microsoft.com/office/drawing/2016/SVG/main" r:embed="rId3"/>
               </a:ext>
             </a:extLst>
           </a:blip>
@@ -4322,8 +4322,8 @@
         </p:nvSpPr>
         <p:spPr>
           <a:xfrm>
-            <a:off x="3484981" y="2832605"/>
-            <a:ext cx="3594435" cy="850303"/>
+            <a:off x="1888693" y="2832605"/>
+            <a:ext cx="5190724" cy="850303"/>
           </a:xfrm>
           <a:prstGeom prst="roundRect">
             <a:avLst>
@@ -4379,7 +4379,7 @@
         </p:nvSpPr>
         <p:spPr>
           <a:xfrm>
-            <a:off x="3853035" y="6269990"/>
+            <a:off x="2269561" y="6269990"/>
             <a:ext cx="1312396" cy="430887"/>
           </a:xfrm>
           <a:prstGeom prst="rect">
@@ -4473,10 +4473,10 @@
           <p:nvPr/>
         </p:nvPicPr>
         <p:blipFill>
-          <a:blip r:embed="rId4">
+          <a:blip>
             <a:extLst>
               <a:ext uri="{96DAC541-7B7A-43D3-8B79-37D633B846F1}">
-                <asvg:svgBlip xmlns:asvg="http://schemas.microsoft.com/office/drawing/2016/SVG/main" r:embed="rId5"/>
+                <asvg:svgBlip xmlns:asvg="http://schemas.microsoft.com/office/drawing/2016/SVG/main" r:embed="rId3"/>
               </a:ext>
             </a:extLst>
           </a:blip>
@@ -4551,8 +4551,8 @@
         </p:nvSpPr>
         <p:spPr>
           <a:xfrm>
-            <a:off x="3484981" y="3885487"/>
-            <a:ext cx="3594435" cy="850303"/>
+            <a:off x="1879205" y="3885487"/>
+            <a:ext cx="5200212" cy="850303"/>
           </a:xfrm>
           <a:prstGeom prst="roundRect">
             <a:avLst>
@@ -4608,8 +4608,8 @@
         </p:nvSpPr>
         <p:spPr>
           <a:xfrm>
-            <a:off x="3484980" y="4990800"/>
-            <a:ext cx="3594435" cy="850303"/>
+            <a:off x="1888692" y="4990800"/>
+            <a:ext cx="5190723" cy="850303"/>
           </a:xfrm>
           <a:prstGeom prst="roundRect">
             <a:avLst>
@@ -4665,7 +4665,7 @@
         </p:nvSpPr>
         <p:spPr>
           <a:xfrm>
-            <a:off x="3494468" y="2863223"/>
+            <a:off x="1888692" y="2863223"/>
             <a:ext cx="1312396" cy="261610"/>
           </a:xfrm>
           <a:prstGeom prst="rect">
@@ -4707,7 +4707,7 @@
         </p:nvSpPr>
         <p:spPr>
           <a:xfrm>
-            <a:off x="3484980" y="3921970"/>
+            <a:off x="1879204" y="3921970"/>
             <a:ext cx="1312396" cy="261610"/>
           </a:xfrm>
           <a:prstGeom prst="rect">
@@ -4749,7 +4749,7 @@
         </p:nvSpPr>
         <p:spPr>
           <a:xfrm>
-            <a:off x="3484980" y="5032405"/>
+            <a:off x="1879204" y="5032405"/>
             <a:ext cx="1312396" cy="261610"/>
           </a:xfrm>
           <a:prstGeom prst="rect">
@@ -4792,10 +4792,10 @@
           <p:nvPr/>
         </p:nvPicPr>
         <p:blipFill>
-          <a:blip r:embed="rId6">
+          <a:blip>
             <a:extLst>
               <a:ext uri="{96DAC541-7B7A-43D3-8B79-37D633B846F1}">
-                <asvg:svgBlip xmlns:asvg="http://schemas.microsoft.com/office/drawing/2016/SVG/main" r:embed="rId7"/>
+                <asvg:svgBlip xmlns:asvg="http://schemas.microsoft.com/office/drawing/2016/SVG/main" r:embed="rId4"/>
               </a:ext>
             </a:extLst>
           </a:blip>
@@ -4805,7 +4805,7 @@
         </p:blipFill>
         <p:spPr>
           <a:xfrm>
-            <a:off x="4320938" y="3124833"/>
+            <a:off x="2715162" y="3124833"/>
             <a:ext cx="376591" cy="376591"/>
           </a:xfrm>
           <a:prstGeom prst="rect">
@@ -4828,10 +4828,10 @@
           <p:nvPr/>
         </p:nvPicPr>
         <p:blipFill>
-          <a:blip r:embed="rId6">
+          <a:blip>
             <a:extLst>
               <a:ext uri="{96DAC541-7B7A-43D3-8B79-37D633B846F1}">
-                <asvg:svgBlip xmlns:asvg="http://schemas.microsoft.com/office/drawing/2016/SVG/main" r:embed="rId7"/>
+                <asvg:svgBlip xmlns:asvg="http://schemas.microsoft.com/office/drawing/2016/SVG/main" r:embed="rId4"/>
               </a:ext>
             </a:extLst>
           </a:blip>
@@ -4841,7 +4841,7 @@
         </p:blipFill>
         <p:spPr>
           <a:xfrm>
-            <a:off x="5994909" y="3124883"/>
+            <a:off x="4389133" y="3124883"/>
             <a:ext cx="376591" cy="376591"/>
           </a:xfrm>
           <a:prstGeom prst="rect">
@@ -4863,7 +4863,7 @@
         </p:nvSpPr>
         <p:spPr>
           <a:xfrm>
-            <a:off x="3845865" y="3479819"/>
+            <a:off x="2240089" y="3479819"/>
             <a:ext cx="1312396" cy="261610"/>
           </a:xfrm>
           <a:prstGeom prst="rect">
@@ -4906,7 +4906,7 @@
         </p:nvSpPr>
         <p:spPr>
           <a:xfrm>
-            <a:off x="5497145" y="3479819"/>
+            <a:off x="3891369" y="3479819"/>
             <a:ext cx="1312396" cy="261610"/>
           </a:xfrm>
           <a:prstGeom prst="rect">
@@ -4950,10 +4950,10 @@
           <p:nvPr/>
         </p:nvPicPr>
         <p:blipFill>
-          <a:blip r:embed="rId6">
+          <a:blip>
             <a:extLst>
               <a:ext uri="{96DAC541-7B7A-43D3-8B79-37D633B846F1}">
-                <asvg:svgBlip xmlns:asvg="http://schemas.microsoft.com/office/drawing/2016/SVG/main" r:embed="rId7"/>
+                <asvg:svgBlip xmlns:asvg="http://schemas.microsoft.com/office/drawing/2016/SVG/main" r:embed="rId4"/>
               </a:ext>
             </a:extLst>
           </a:blip>
@@ -4963,7 +4963,7 @@
         </p:blipFill>
         <p:spPr>
           <a:xfrm>
-            <a:off x="4320938" y="4183530"/>
+            <a:off x="2715162" y="4183530"/>
             <a:ext cx="376591" cy="376591"/>
           </a:xfrm>
           <a:prstGeom prst="rect">
@@ -4986,10 +4986,10 @@
           <p:nvPr/>
         </p:nvPicPr>
         <p:blipFill>
-          <a:blip r:embed="rId6">
+          <a:blip>
             <a:extLst>
               <a:ext uri="{96DAC541-7B7A-43D3-8B79-37D633B846F1}">
-                <asvg:svgBlip xmlns:asvg="http://schemas.microsoft.com/office/drawing/2016/SVG/main" r:embed="rId7"/>
+                <asvg:svgBlip xmlns:asvg="http://schemas.microsoft.com/office/drawing/2016/SVG/main" r:embed="rId4"/>
               </a:ext>
             </a:extLst>
           </a:blip>
@@ -4999,7 +4999,7 @@
         </p:blipFill>
         <p:spPr>
           <a:xfrm>
-            <a:off x="5994909" y="4183580"/>
+            <a:off x="4389133" y="4183580"/>
             <a:ext cx="376591" cy="376591"/>
           </a:xfrm>
           <a:prstGeom prst="rect">
@@ -5021,7 +5021,7 @@
         </p:nvSpPr>
         <p:spPr>
           <a:xfrm>
-            <a:off x="3845865" y="4538516"/>
+            <a:off x="2240089" y="4538516"/>
             <a:ext cx="1312396" cy="261610"/>
           </a:xfrm>
           <a:prstGeom prst="rect">
@@ -5071,7 +5071,7 @@
         </p:nvSpPr>
         <p:spPr>
           <a:xfrm>
-            <a:off x="5497145" y="4538516"/>
+            <a:off x="3891369" y="4538516"/>
             <a:ext cx="1312396" cy="261610"/>
           </a:xfrm>
           <a:prstGeom prst="rect">
@@ -5122,10 +5122,10 @@
           <p:nvPr/>
         </p:nvPicPr>
         <p:blipFill>
-          <a:blip r:embed="rId6">
+          <a:blip>
             <a:extLst>
               <a:ext uri="{96DAC541-7B7A-43D3-8B79-37D633B846F1}">
-                <asvg:svgBlip xmlns:asvg="http://schemas.microsoft.com/office/drawing/2016/SVG/main" r:embed="rId7"/>
+                <asvg:svgBlip xmlns:asvg="http://schemas.microsoft.com/office/drawing/2016/SVG/main" r:embed="rId4"/>
               </a:ext>
             </a:extLst>
           </a:blip>
@@ -5135,7 +5135,7 @@
         </p:blipFill>
         <p:spPr>
           <a:xfrm>
-            <a:off x="4299783" y="5284866"/>
+            <a:off x="2694007" y="5284866"/>
             <a:ext cx="376591" cy="376591"/>
           </a:xfrm>
           <a:prstGeom prst="rect">
@@ -5158,10 +5158,10 @@
           <p:nvPr/>
         </p:nvPicPr>
         <p:blipFill>
-          <a:blip r:embed="rId6">
+          <a:blip>
             <a:extLst>
               <a:ext uri="{96DAC541-7B7A-43D3-8B79-37D633B846F1}">
-                <asvg:svgBlip xmlns:asvg="http://schemas.microsoft.com/office/drawing/2016/SVG/main" r:embed="rId7"/>
+                <asvg:svgBlip xmlns:asvg="http://schemas.microsoft.com/office/drawing/2016/SVG/main" r:embed="rId4"/>
               </a:ext>
             </a:extLst>
           </a:blip>
@@ -5171,7 +5171,7 @@
         </p:blipFill>
         <p:spPr>
           <a:xfrm>
-            <a:off x="5973754" y="5284916"/>
+            <a:off x="4367978" y="5284916"/>
             <a:ext cx="376591" cy="376591"/>
           </a:xfrm>
           <a:prstGeom prst="rect">
@@ -5193,7 +5193,7 @@
         </p:nvSpPr>
         <p:spPr>
           <a:xfrm>
-            <a:off x="3824710" y="5639852"/>
+            <a:off x="2218934" y="5639852"/>
             <a:ext cx="1312396" cy="261610"/>
           </a:xfrm>
           <a:prstGeom prst="rect">
@@ -5243,7 +5243,7 @@
         </p:nvSpPr>
         <p:spPr>
           <a:xfrm>
-            <a:off x="5475990" y="5639852"/>
+            <a:off x="3870214" y="5639852"/>
             <a:ext cx="1312396" cy="261610"/>
           </a:xfrm>
           <a:prstGeom prst="rect">
@@ -5294,10 +5294,10 @@
           <p:nvPr/>
         </p:nvPicPr>
         <p:blipFill>
-          <a:blip r:embed="rId8">
+          <a:blip>
             <a:extLst>
               <a:ext uri="{96DAC541-7B7A-43D3-8B79-37D633B846F1}">
-                <asvg:svgBlip xmlns:asvg="http://schemas.microsoft.com/office/drawing/2016/SVG/main" r:embed="rId9"/>
+                <asvg:svgBlip xmlns:asvg="http://schemas.microsoft.com/office/drawing/2016/SVG/main" r:embed="rId5"/>
               </a:ext>
             </a:extLst>
           </a:blip>
@@ -5307,7 +5307,7 @@
         </p:blipFill>
         <p:spPr>
           <a:xfrm>
-            <a:off x="4915538" y="3176340"/>
+            <a:off x="3309762" y="3176340"/>
             <a:ext cx="279755" cy="279755"/>
           </a:xfrm>
           <a:prstGeom prst="rect">
@@ -5330,10 +5330,10 @@
           <p:nvPr/>
         </p:nvPicPr>
         <p:blipFill>
-          <a:blip r:embed="rId8">
+          <a:blip>
             <a:extLst>
               <a:ext uri="{96DAC541-7B7A-43D3-8B79-37D633B846F1}">
-                <asvg:svgBlip xmlns:asvg="http://schemas.microsoft.com/office/drawing/2016/SVG/main" r:embed="rId9"/>
+                <asvg:svgBlip xmlns:asvg="http://schemas.microsoft.com/office/drawing/2016/SVG/main" r:embed="rId5"/>
               </a:ext>
             </a:extLst>
           </a:blip>
@@ -5343,7 +5343,7 @@
         </p:blipFill>
         <p:spPr>
           <a:xfrm>
-            <a:off x="6626620" y="3176340"/>
+            <a:off x="5020844" y="3176340"/>
             <a:ext cx="279755" cy="279755"/>
           </a:xfrm>
           <a:prstGeom prst="rect">
@@ -5365,7 +5365,7 @@
         </p:nvSpPr>
         <p:spPr>
           <a:xfrm>
-            <a:off x="4785176" y="3428034"/>
+            <a:off x="3179400" y="3428034"/>
             <a:ext cx="541601" cy="261610"/>
           </a:xfrm>
           <a:prstGeom prst="rect">
@@ -5408,7 +5408,7 @@
         </p:nvSpPr>
         <p:spPr>
           <a:xfrm>
-            <a:off x="6486960" y="3419460"/>
+            <a:off x="4881569" y="3452795"/>
             <a:ext cx="541601" cy="261610"/>
           </a:xfrm>
           <a:prstGeom prst="rect">
@@ -5452,10 +5452,10 @@
           <p:nvPr/>
         </p:nvPicPr>
         <p:blipFill>
-          <a:blip r:embed="rId8">
+          <a:blip>
             <a:extLst>
               <a:ext uri="{96DAC541-7B7A-43D3-8B79-37D633B846F1}">
-                <asvg:svgBlip xmlns:asvg="http://schemas.microsoft.com/office/drawing/2016/SVG/main" r:embed="rId9"/>
+                <asvg:svgBlip xmlns:asvg="http://schemas.microsoft.com/office/drawing/2016/SVG/main" r:embed="rId5"/>
               </a:ext>
             </a:extLst>
           </a:blip>
@@ -5465,7 +5465,7 @@
         </p:blipFill>
         <p:spPr>
           <a:xfrm>
-            <a:off x="4898451" y="4222940"/>
+            <a:off x="3292675" y="4222940"/>
             <a:ext cx="279755" cy="279755"/>
           </a:xfrm>
           <a:prstGeom prst="rect">
@@ -5488,10 +5488,10 @@
           <p:nvPr/>
         </p:nvPicPr>
         <p:blipFill>
-          <a:blip r:embed="rId8">
+          <a:blip>
             <a:extLst>
               <a:ext uri="{96DAC541-7B7A-43D3-8B79-37D633B846F1}">
-                <asvg:svgBlip xmlns:asvg="http://schemas.microsoft.com/office/drawing/2016/SVG/main" r:embed="rId9"/>
+                <asvg:svgBlip xmlns:asvg="http://schemas.microsoft.com/office/drawing/2016/SVG/main" r:embed="rId5"/>
               </a:ext>
             </a:extLst>
           </a:blip>
@@ -5501,7 +5501,7 @@
         </p:blipFill>
         <p:spPr>
           <a:xfrm>
-            <a:off x="6609533" y="4222940"/>
+            <a:off x="5003757" y="4222940"/>
             <a:ext cx="279755" cy="279755"/>
           </a:xfrm>
           <a:prstGeom prst="rect">
@@ -5523,7 +5523,7 @@
         </p:nvSpPr>
         <p:spPr>
           <a:xfrm>
-            <a:off x="4768089" y="4474634"/>
+            <a:off x="3162313" y="4474634"/>
             <a:ext cx="541601" cy="261610"/>
           </a:xfrm>
           <a:prstGeom prst="rect">
@@ -5566,7 +5566,7 @@
         </p:nvSpPr>
         <p:spPr>
           <a:xfrm>
-            <a:off x="6469873" y="4466060"/>
+            <a:off x="4864097" y="4466060"/>
             <a:ext cx="541601" cy="261610"/>
           </a:xfrm>
           <a:prstGeom prst="rect">
@@ -5610,10 +5610,10 @@
           <p:nvPr/>
         </p:nvPicPr>
         <p:blipFill>
-          <a:blip r:embed="rId8">
+          <a:blip>
             <a:extLst>
               <a:ext uri="{96DAC541-7B7A-43D3-8B79-37D633B846F1}">
-                <asvg:svgBlip xmlns:asvg="http://schemas.microsoft.com/office/drawing/2016/SVG/main" r:embed="rId9"/>
+                <asvg:svgBlip xmlns:asvg="http://schemas.microsoft.com/office/drawing/2016/SVG/main" r:embed="rId5"/>
               </a:ext>
             </a:extLst>
           </a:blip>
@@ -5623,7 +5623,7 @@
         </p:blipFill>
         <p:spPr>
           <a:xfrm>
-            <a:off x="4898451" y="5385961"/>
+            <a:off x="3292675" y="5385961"/>
             <a:ext cx="279755" cy="279755"/>
           </a:xfrm>
           <a:prstGeom prst="rect">
@@ -5646,10 +5646,10 @@
           <p:nvPr/>
         </p:nvPicPr>
         <p:blipFill>
-          <a:blip r:embed="rId8">
+          <a:blip>
             <a:extLst>
               <a:ext uri="{96DAC541-7B7A-43D3-8B79-37D633B846F1}">
-                <asvg:svgBlip xmlns:asvg="http://schemas.microsoft.com/office/drawing/2016/SVG/main" r:embed="rId9"/>
+                <asvg:svgBlip xmlns:asvg="http://schemas.microsoft.com/office/drawing/2016/SVG/main" r:embed="rId5"/>
               </a:ext>
             </a:extLst>
           </a:blip>
@@ -5659,7 +5659,7 @@
         </p:blipFill>
         <p:spPr>
           <a:xfrm>
-            <a:off x="6609533" y="5385961"/>
+            <a:off x="5003757" y="5385961"/>
             <a:ext cx="279755" cy="279755"/>
           </a:xfrm>
           <a:prstGeom prst="rect">
@@ -5681,7 +5681,7 @@
         </p:nvSpPr>
         <p:spPr>
           <a:xfrm>
-            <a:off x="4768089" y="5637655"/>
+            <a:off x="3162313" y="5637655"/>
             <a:ext cx="541601" cy="261610"/>
           </a:xfrm>
           <a:prstGeom prst="rect">
@@ -5724,7 +5724,7 @@
         </p:nvSpPr>
         <p:spPr>
           <a:xfrm>
-            <a:off x="6469873" y="5629081"/>
+            <a:off x="4864097" y="5629081"/>
             <a:ext cx="541601" cy="261610"/>
           </a:xfrm>
           <a:prstGeom prst="rect">
@@ -5767,7 +5767,7 @@
         </p:nvSpPr>
         <p:spPr>
           <a:xfrm>
-            <a:off x="5492897" y="2450537"/>
+            <a:off x="3887121" y="2450537"/>
             <a:ext cx="1377323" cy="430887"/>
           </a:xfrm>
           <a:prstGeom prst="rect">
@@ -5810,10 +5810,10 @@
           <p:nvPr/>
         </p:nvPicPr>
         <p:blipFill>
-          <a:blip r:embed="rId10">
+          <a:blip>
             <a:extLst>
               <a:ext uri="{96DAC541-7B7A-43D3-8B79-37D633B846F1}">
-                <asvg:svgBlip xmlns:asvg="http://schemas.microsoft.com/office/drawing/2016/SVG/main" r:embed="rId11"/>
+                <asvg:svgBlip xmlns:asvg="http://schemas.microsoft.com/office/drawing/2016/SVG/main" r:embed="rId6"/>
               </a:ext>
             </a:extLst>
           </a:blip>
@@ -5823,7 +5823,7 @@
         </p:blipFill>
         <p:spPr>
           <a:xfrm>
-            <a:off x="5221462" y="3761579"/>
+            <a:off x="3615686" y="3761579"/>
             <a:ext cx="279755" cy="279755"/>
           </a:xfrm>
           <a:prstGeom prst="rect">
@@ -5845,7 +5845,7 @@
         </p:nvSpPr>
         <p:spPr>
           <a:xfrm>
-            <a:off x="5424542" y="3646255"/>
+            <a:off x="3818766" y="3646255"/>
             <a:ext cx="398505" cy="261610"/>
           </a:xfrm>
           <a:prstGeom prst="rect">
@@ -5889,10 +5889,10 @@
           <p:nvPr/>
         </p:nvPicPr>
         <p:blipFill>
-          <a:blip r:embed="rId12">
+          <a:blip>
             <a:extLst>
               <a:ext uri="{96DAC541-7B7A-43D3-8B79-37D633B846F1}">
-                <asvg:svgBlip xmlns:asvg="http://schemas.microsoft.com/office/drawing/2016/SVG/main" r:embed="rId13"/>
+                <asvg:svgBlip xmlns:asvg="http://schemas.microsoft.com/office/drawing/2016/SVG/main" r:embed="rId7"/>
               </a:ext>
             </a:extLst>
           </a:blip>
@@ -5968,10 +5968,10 @@
           <p:nvPr/>
         </p:nvPicPr>
         <p:blipFill>
-          <a:blip r:embed="rId14">
+          <a:blip>
             <a:extLst>
               <a:ext uri="{96DAC541-7B7A-43D3-8B79-37D633B846F1}">
-                <asvg:svgBlip xmlns:asvg="http://schemas.microsoft.com/office/drawing/2016/SVG/main" r:embed="rId15"/>
+                <asvg:svgBlip xmlns:asvg="http://schemas.microsoft.com/office/drawing/2016/SVG/main" r:embed="rId8"/>
               </a:ext>
             </a:extLst>
           </a:blip>
@@ -6047,10 +6047,10 @@
           <p:nvPr/>
         </p:nvPicPr>
         <p:blipFill>
-          <a:blip r:embed="rId16">
+          <a:blip>
             <a:extLst>
               <a:ext uri="{96DAC541-7B7A-43D3-8B79-37D633B846F1}">
-                <asvg:svgBlip xmlns:asvg="http://schemas.microsoft.com/office/drawing/2016/SVG/main" r:embed="rId17"/>
+                <asvg:svgBlip xmlns:asvg="http://schemas.microsoft.com/office/drawing/2016/SVG/main" r:embed="rId9"/>
               </a:ext>
             </a:extLst>
           </a:blip>
@@ -6126,10 +6126,10 @@
           <p:nvPr/>
         </p:nvPicPr>
         <p:blipFill>
-          <a:blip r:embed="rId18">
+          <a:blip>
             <a:extLst>
               <a:ext uri="{96DAC541-7B7A-43D3-8B79-37D633B846F1}">
-                <asvg:svgBlip xmlns:asvg="http://schemas.microsoft.com/office/drawing/2016/SVG/main" r:embed="rId19"/>
+                <asvg:svgBlip xmlns:asvg="http://schemas.microsoft.com/office/drawing/2016/SVG/main" r:embed="rId10"/>
               </a:ext>
             </a:extLst>
           </a:blip>
@@ -6204,7 +6204,7 @@
         </p:nvSpPr>
         <p:spPr>
           <a:xfrm>
-            <a:off x="5533487" y="6269990"/>
+            <a:off x="3950013" y="6269990"/>
             <a:ext cx="1312396" cy="430887"/>
           </a:xfrm>
           <a:prstGeom prst="rect">
@@ -6262,10 +6262,10 @@
           <p:nvPr/>
         </p:nvPicPr>
         <p:blipFill>
-          <a:blip r:embed="rId20">
+          <a:blip>
             <a:extLst>
               <a:ext uri="{96DAC541-7B7A-43D3-8B79-37D633B846F1}">
-                <asvg:svgBlip xmlns:asvg="http://schemas.microsoft.com/office/drawing/2016/SVG/main" r:embed="rId21"/>
+                <asvg:svgBlip xmlns:asvg="http://schemas.microsoft.com/office/drawing/2016/SVG/main" r:embed="rId11"/>
               </a:ext>
             </a:extLst>
           </a:blip>
@@ -6275,7 +6275,7 @@
         </p:blipFill>
         <p:spPr>
           <a:xfrm>
-            <a:off x="5186665" y="2606599"/>
+            <a:off x="3580889" y="2606599"/>
             <a:ext cx="344318" cy="344318"/>
           </a:xfrm>
           <a:prstGeom prst="rect">
@@ -6298,10 +6298,10 @@
           <p:nvPr/>
         </p:nvPicPr>
         <p:blipFill>
-          <a:blip r:embed="rId22">
+          <a:blip>
             <a:extLst>
               <a:ext uri="{96DAC541-7B7A-43D3-8B79-37D633B846F1}">
-                <asvg:svgBlip xmlns:asvg="http://schemas.microsoft.com/office/drawing/2016/SVG/main" r:embed="rId23"/>
+                <asvg:svgBlip xmlns:asvg="http://schemas.microsoft.com/office/drawing/2016/SVG/main" r:embed="rId12"/>
               </a:ext>
             </a:extLst>
           </a:blip>
@@ -6377,10 +6377,10 @@
           <p:nvPr/>
         </p:nvPicPr>
         <p:blipFill>
-          <a:blip r:embed="rId24">
+          <a:blip>
             <a:extLst>
               <a:ext uri="{96DAC541-7B7A-43D3-8B79-37D633B846F1}">
-                <asvg:svgBlip xmlns:asvg="http://schemas.microsoft.com/office/drawing/2016/SVG/main" r:embed="rId25"/>
+                <asvg:svgBlip xmlns:asvg="http://schemas.microsoft.com/office/drawing/2016/SVG/main" r:embed="rId13"/>
               </a:ext>
             </a:extLst>
           </a:blip>
@@ -6390,7 +6390,7 @@
         </p:blipFill>
         <p:spPr>
           <a:xfrm>
-            <a:off x="5225999" y="2168558"/>
+            <a:off x="3620223" y="2168558"/>
             <a:ext cx="258238" cy="258238"/>
           </a:xfrm>
           <a:prstGeom prst="rect">
@@ -6415,7 +6415,7 @@
         </p:nvCxnSpPr>
         <p:spPr>
           <a:xfrm>
-            <a:off x="5355118" y="2426796"/>
+            <a:off x="3749342" y="2426796"/>
             <a:ext cx="3706" cy="179803"/>
           </a:xfrm>
           <a:prstGeom prst="line">
@@ -6451,7 +6451,7 @@
         </p:nvSpPr>
         <p:spPr>
           <a:xfrm>
-            <a:off x="5455620" y="1915172"/>
+            <a:off x="3850077" y="2082465"/>
             <a:ext cx="1377323" cy="261610"/>
           </a:xfrm>
           <a:prstGeom prst="rect">
@@ -6650,10 +6650,10 @@
           <p:nvPr/>
         </p:nvPicPr>
         <p:blipFill>
-          <a:blip r:embed="rId26">
+          <a:blip>
             <a:extLst>
               <a:ext uri="{96DAC541-7B7A-43D3-8B79-37D633B846F1}">
-                <asvg:svgBlip xmlns:asvg="http://schemas.microsoft.com/office/drawing/2016/SVG/main" r:embed="rId27"/>
+                <asvg:svgBlip xmlns:asvg="http://schemas.microsoft.com/office/drawing/2016/SVG/main" r:embed="rId14"/>
               </a:ext>
             </a:extLst>
           </a:blip>
@@ -6715,58 +6715,7 @@
       </p:sp>
       <mc:AlternateContent xmlns:mc="http://schemas.openxmlformats.org/markup-compatibility/2006" xmlns:p14="http://schemas.microsoft.com/office/powerpoint/2010/main">
         <mc:Choice Requires="p14">
-          <p:contentPart p14:bwMode="auto" r:id="rId28">
-            <p14:nvContentPartPr>
-              <p14:cNvPr id="79" name="インク 78">
-                <a:extLst>
-                  <a:ext uri="{FF2B5EF4-FFF2-40B4-BE49-F238E27FC236}">
-                    <a16:creationId xmlns:a16="http://schemas.microsoft.com/office/drawing/2014/main" id="{67167464-E0BD-ABA8-23A3-697B83D796C3}"/>
-                  </a:ext>
-                </a:extLst>
-              </p14:cNvPr>
-              <p14:cNvContentPartPr/>
-              <p14:nvPr/>
-            </p14:nvContentPartPr>
-            <p14:xfrm>
-              <a:off x="3728451" y="858771"/>
-              <a:ext cx="1627920" cy="1096200"/>
-            </p14:xfrm>
-          </p:contentPart>
-        </mc:Choice>
-        <mc:Fallback xmlns="">
-          <p:pic>
-            <p:nvPicPr>
-              <p:cNvPr id="79" name="インク 78">
-                <a:extLst>
-                  <a:ext uri="{FF2B5EF4-FFF2-40B4-BE49-F238E27FC236}">
-                    <a16:creationId xmlns:a16="http://schemas.microsoft.com/office/drawing/2014/main" id="{67167464-E0BD-ABA8-23A3-697B83D796C3}"/>
-                  </a:ext>
-                </a:extLst>
-              </p:cNvPr>
-              <p:cNvPicPr/>
-              <p:nvPr/>
-            </p:nvPicPr>
-            <p:blipFill>
-              <a:blip r:embed="rId29"/>
-              <a:stretch>
-                <a:fillRect/>
-              </a:stretch>
-            </p:blipFill>
-            <p:spPr>
-              <a:xfrm>
-                <a:off x="3722331" y="852651"/>
-                <a:ext cx="1640160" cy="1108440"/>
-              </a:xfrm>
-              <a:prstGeom prst="rect">
-                <a:avLst/>
-              </a:prstGeom>
-            </p:spPr>
-          </p:pic>
-        </mc:Fallback>
-      </mc:AlternateContent>
-      <mc:AlternateContent xmlns:mc="http://schemas.openxmlformats.org/markup-compatibility/2006" xmlns:p14="http://schemas.microsoft.com/office/powerpoint/2010/main">
-        <mc:Choice Requires="p14">
-          <p:contentPart p14:bwMode="auto" r:id="rId30">
+          <p:contentPart p14:bwMode="auto" r:id="rId15">
             <p14:nvContentPartPr>
               <p14:cNvPr id="80" name="インク 79">
                 <a:extLst>
@@ -6779,7 +6728,7 @@
               <p14:nvPr/>
             </p14:nvContentPartPr>
             <p14:xfrm>
-              <a:off x="5224971" y="1875051"/>
+              <a:off x="3619195" y="1875051"/>
               <a:ext cx="185040" cy="127800"/>
             </p14:xfrm>
           </p:contentPart>
@@ -6798,15 +6747,15 @@
               <p:nvPr/>
             </p:nvPicPr>
             <p:blipFill>
-              <a:blip r:embed="rId31"/>
+              <a:blip r:embed="rId16"/>
               <a:stretch>
                 <a:fillRect/>
               </a:stretch>
             </p:blipFill>
             <p:spPr>
               <a:xfrm>
-                <a:off x="5218851" y="1868931"/>
-                <a:ext cx="197280" cy="140040"/>
+                <a:off x="3613075" y="1868914"/>
+                <a:ext cx="197280" cy="140075"/>
               </a:xfrm>
               <a:prstGeom prst="rect">
                 <a:avLst/>
@@ -6829,7 +6778,7 @@
         </p:nvSpPr>
         <p:spPr>
           <a:xfrm>
-            <a:off x="2950029" y="1262743"/>
+            <a:off x="2212051" y="1117376"/>
             <a:ext cx="1726345" cy="430887"/>
           </a:xfrm>
           <a:prstGeom prst="rect">
@@ -6878,10 +6827,10 @@
           <p:nvPr/>
         </p:nvPicPr>
         <p:blipFill>
-          <a:blip r:embed="rId32">
+          <a:blip>
             <a:extLst>
               <a:ext uri="{96DAC541-7B7A-43D3-8B79-37D633B846F1}">
-                <asvg:svgBlip xmlns:asvg="http://schemas.microsoft.com/office/drawing/2016/SVG/main" r:embed="rId33"/>
+                <asvg:svgBlip xmlns:asvg="http://schemas.microsoft.com/office/drawing/2016/SVG/main" r:embed="rId17"/>
               </a:ext>
             </a:extLst>
           </a:blip>
@@ -7116,7 +7065,7 @@
         </p:grpSpPr>
         <mc:AlternateContent xmlns:mc="http://schemas.openxmlformats.org/markup-compatibility/2006" xmlns:p14="http://schemas.microsoft.com/office/powerpoint/2010/main">
           <mc:Choice Requires="p14">
-            <p:contentPart p14:bwMode="auto" r:id="rId34">
+            <p:contentPart p14:bwMode="auto" r:id="rId18">
               <p14:nvContentPartPr>
                 <p14:cNvPr id="87" name="インク 86">
                   <a:extLst>
@@ -7316,12 +7265,394 @@
           </p:pic>
         </mc:Fallback>
       </mc:AlternateContent>
+      <p:sp>
+        <p:nvSpPr>
+          <p:cNvPr id="112" name="テキスト ボックス 111">
+            <a:extLst>
+              <a:ext uri="{FF2B5EF4-FFF2-40B4-BE49-F238E27FC236}">
+                <a16:creationId xmlns:a16="http://schemas.microsoft.com/office/drawing/2014/main" id="{C1F7DE73-C89B-A3B3-55F9-3B74659430A4}"/>
+              </a:ext>
+            </a:extLst>
+          </p:cNvPr>
+          <p:cNvSpPr txBox="1"/>
+          <p:nvPr/>
+        </p:nvSpPr>
+        <p:spPr>
+          <a:xfrm>
+            <a:off x="6926569" y="1397411"/>
+            <a:ext cx="1726345" cy="430887"/>
+          </a:xfrm>
+          <a:prstGeom prst="rect">
+            <a:avLst/>
+          </a:prstGeom>
+          <a:noFill/>
+        </p:spPr>
+        <p:txBody>
+          <a:bodyPr wrap="square" rtlCol="0">
+            <a:spAutoFit/>
+          </a:bodyPr>
+          <a:lstStyle/>
+          <a:p>
+            <a:r>
+              <a:rPr lang="en-US" altLang="ja-JP" sz="1100" dirty="0">
+                <a:solidFill>
+                  <a:srgbClr val="FF0000"/>
+                </a:solidFill>
+                <a:latin typeface="Segoe UI" panose="020B0502040204020203" pitchFamily="34" charset="0"/>
+                <a:cs typeface="Segoe UI" panose="020B0502040204020203" pitchFamily="34" charset="0"/>
+              </a:rPr>
+              <a:t>Configure VMs and implement applications</a:t>
+            </a:r>
+            <a:endParaRPr kumimoji="1" lang="ja-JP" altLang="en-US" sz="1100">
+              <a:solidFill>
+                <a:srgbClr val="FF0000"/>
+              </a:solidFill>
+              <a:latin typeface="Segoe UI" panose="020B0502040204020203" pitchFamily="34" charset="0"/>
+              <a:cs typeface="Segoe UI" panose="020B0502040204020203" pitchFamily="34" charset="0"/>
+            </a:endParaRPr>
+          </a:p>
+        </p:txBody>
+      </p:sp>
+      <p:pic>
+        <p:nvPicPr>
+          <p:cNvPr id="2" name="グラフィックス 1">
+            <a:extLst>
+              <a:ext uri="{FF2B5EF4-FFF2-40B4-BE49-F238E27FC236}">
+                <a16:creationId xmlns:a16="http://schemas.microsoft.com/office/drawing/2014/main" id="{73ADDD17-5886-8302-054F-6C5873F56456}"/>
+              </a:ext>
+            </a:extLst>
+          </p:cNvPr>
+          <p:cNvPicPr>
+            <a:picLocks noChangeAspect="1"/>
+          </p:cNvPicPr>
+          <p:nvPr/>
+        </p:nvPicPr>
+        <p:blipFill>
+          <a:blip>
+            <a:extLst>
+              <a:ext uri="{96DAC541-7B7A-43D3-8B79-37D633B846F1}">
+                <asvg:svgBlip xmlns:asvg="http://schemas.microsoft.com/office/drawing/2016/SVG/main" r:embed="rId4"/>
+              </a:ext>
+            </a:extLst>
+          </a:blip>
+          <a:stretch>
+            <a:fillRect/>
+          </a:stretch>
+        </p:blipFill>
+        <p:spPr>
+          <a:xfrm>
+            <a:off x="5813649" y="5272959"/>
+            <a:ext cx="376591" cy="376591"/>
+          </a:xfrm>
+          <a:prstGeom prst="rect">
+            <a:avLst/>
+          </a:prstGeom>
+        </p:spPr>
+      </p:pic>
+      <p:sp>
+        <p:nvSpPr>
+          <p:cNvPr id="3" name="テキスト ボックス 2">
+            <a:extLst>
+              <a:ext uri="{FF2B5EF4-FFF2-40B4-BE49-F238E27FC236}">
+                <a16:creationId xmlns:a16="http://schemas.microsoft.com/office/drawing/2014/main" id="{4FC61441-B47C-CBF2-8B5F-05683BDD6112}"/>
+              </a:ext>
+            </a:extLst>
+          </p:cNvPr>
+          <p:cNvSpPr txBox="1"/>
+          <p:nvPr/>
+        </p:nvSpPr>
+        <p:spPr>
+          <a:xfrm>
+            <a:off x="5315885" y="5627895"/>
+            <a:ext cx="1312396" cy="261610"/>
+          </a:xfrm>
+          <a:prstGeom prst="rect">
+            <a:avLst/>
+          </a:prstGeom>
+          <a:noFill/>
+        </p:spPr>
+        <p:txBody>
+          <a:bodyPr wrap="square" rtlCol="0">
+            <a:spAutoFit/>
+          </a:bodyPr>
+          <a:lstStyle/>
+          <a:p>
+            <a:pPr algn="ctr"/>
+            <a:r>
+              <a:rPr lang="en-US" altLang="ja-JP" sz="1100" dirty="0">
+                <a:latin typeface="Segoe UI" panose="020B0502040204020203" pitchFamily="34" charset="0"/>
+                <a:cs typeface="Segoe UI" panose="020B0502040204020203" pitchFamily="34" charset="0"/>
+              </a:rPr>
+              <a:t>DB</a:t>
+            </a:r>
+            <a:r>
+              <a:rPr kumimoji="1" lang="en-US" altLang="ja-JP" sz="1100" dirty="0">
+                <a:latin typeface="Segoe UI" panose="020B0502040204020203" pitchFamily="34" charset="0"/>
+                <a:cs typeface="Segoe UI" panose="020B0502040204020203" pitchFamily="34" charset="0"/>
+              </a:rPr>
+              <a:t> VM</a:t>
+            </a:r>
+            <a:endParaRPr kumimoji="1" lang="ja-JP" altLang="en-US" sz="1100">
+              <a:latin typeface="Segoe UI" panose="020B0502040204020203" pitchFamily="34" charset="0"/>
+              <a:cs typeface="Segoe UI" panose="020B0502040204020203" pitchFamily="34" charset="0"/>
+            </a:endParaRPr>
+          </a:p>
+        </p:txBody>
+      </p:sp>
+      <p:pic>
+        <p:nvPicPr>
+          <p:cNvPr id="14" name="グラフィックス 13">
+            <a:extLst>
+              <a:ext uri="{FF2B5EF4-FFF2-40B4-BE49-F238E27FC236}">
+                <a16:creationId xmlns:a16="http://schemas.microsoft.com/office/drawing/2014/main" id="{9624730A-E6DD-F9BA-F975-00AD5BC2C405}"/>
+              </a:ext>
+            </a:extLst>
+          </p:cNvPr>
+          <p:cNvPicPr>
+            <a:picLocks noChangeAspect="1"/>
+          </p:cNvPicPr>
+          <p:nvPr/>
+        </p:nvPicPr>
+        <p:blipFill>
+          <a:blip>
+            <a:extLst>
+              <a:ext uri="{96DAC541-7B7A-43D3-8B79-37D633B846F1}">
+                <asvg:svgBlip xmlns:asvg="http://schemas.microsoft.com/office/drawing/2016/SVG/main" r:embed="rId5"/>
+              </a:ext>
+            </a:extLst>
+          </a:blip>
+          <a:stretch>
+            <a:fillRect/>
+          </a:stretch>
+        </p:blipFill>
+        <p:spPr>
+          <a:xfrm>
+            <a:off x="6449428" y="5374004"/>
+            <a:ext cx="279755" cy="279755"/>
+          </a:xfrm>
+          <a:prstGeom prst="rect">
+            <a:avLst/>
+          </a:prstGeom>
+        </p:spPr>
+      </p:pic>
+      <p:sp>
+        <p:nvSpPr>
+          <p:cNvPr id="47" name="テキスト ボックス 46">
+            <a:extLst>
+              <a:ext uri="{FF2B5EF4-FFF2-40B4-BE49-F238E27FC236}">
+                <a16:creationId xmlns:a16="http://schemas.microsoft.com/office/drawing/2014/main" id="{617298C3-5A78-9A8F-4B55-1731E2C686BF}"/>
+              </a:ext>
+            </a:extLst>
+          </p:cNvPr>
+          <p:cNvSpPr txBox="1"/>
+          <p:nvPr/>
+        </p:nvSpPr>
+        <p:spPr>
+          <a:xfrm>
+            <a:off x="6309768" y="5617124"/>
+            <a:ext cx="541601" cy="261610"/>
+          </a:xfrm>
+          <a:prstGeom prst="rect">
+            <a:avLst/>
+          </a:prstGeom>
+          <a:noFill/>
+        </p:spPr>
+        <p:txBody>
+          <a:bodyPr wrap="square" rtlCol="0">
+            <a:spAutoFit/>
+          </a:bodyPr>
+          <a:lstStyle/>
+          <a:p>
+            <a:pPr algn="ctr"/>
+            <a:r>
+              <a:rPr kumimoji="1" lang="en-US" altLang="ja-JP" sz="1100" dirty="0">
+                <a:latin typeface="Segoe UI" panose="020B0502040204020203" pitchFamily="34" charset="0"/>
+                <a:cs typeface="Segoe UI" panose="020B0502040204020203" pitchFamily="34" charset="0"/>
+              </a:rPr>
+              <a:t>Disk</a:t>
+            </a:r>
+            <a:endParaRPr kumimoji="1" lang="ja-JP" altLang="en-US" sz="1100">
+              <a:latin typeface="Segoe UI" panose="020B0502040204020203" pitchFamily="34" charset="0"/>
+              <a:cs typeface="Segoe UI" panose="020B0502040204020203" pitchFamily="34" charset="0"/>
+            </a:endParaRPr>
+          </a:p>
+        </p:txBody>
+      </p:sp>
+      <p:sp>
+        <p:nvSpPr>
+          <p:cNvPr id="51" name="正方形/長方形 50">
+            <a:extLst>
+              <a:ext uri="{FF2B5EF4-FFF2-40B4-BE49-F238E27FC236}">
+                <a16:creationId xmlns:a16="http://schemas.microsoft.com/office/drawing/2014/main" id="{941098FC-9B56-3BE1-F637-4CB000FBAA91}"/>
+              </a:ext>
+            </a:extLst>
+          </p:cNvPr>
+          <p:cNvSpPr/>
+          <p:nvPr/>
+        </p:nvSpPr>
+        <p:spPr>
+          <a:xfrm>
+            <a:off x="5497862" y="1978147"/>
+            <a:ext cx="1482764" cy="4768676"/>
+          </a:xfrm>
+          <a:prstGeom prst="rect">
+            <a:avLst/>
+          </a:prstGeom>
+          <a:noFill/>
+          <a:ln>
+            <a:solidFill>
+              <a:schemeClr val="bg2">
+                <a:lumMod val="75000"/>
+              </a:schemeClr>
+            </a:solidFill>
+            <a:prstDash val="dash"/>
+          </a:ln>
+        </p:spPr>
+        <p:style>
+          <a:lnRef idx="2">
+            <a:schemeClr val="accent1">
+              <a:shade val="15000"/>
+            </a:schemeClr>
+          </a:lnRef>
+          <a:fillRef idx="1">
+            <a:schemeClr val="accent1"/>
+          </a:fillRef>
+          <a:effectRef idx="0">
+            <a:schemeClr val="accent1"/>
+          </a:effectRef>
+          <a:fontRef idx="minor">
+            <a:schemeClr val="lt1"/>
+          </a:fontRef>
+        </p:style>
+        <p:txBody>
+          <a:bodyPr rtlCol="0" anchor="ctr"/>
+          <a:lstStyle/>
+          <a:p>
+            <a:pPr algn="ctr"/>
+            <a:endParaRPr kumimoji="1" lang="ja-JP" altLang="en-US">
+              <a:latin typeface="Segoe UI" panose="020B0502040204020203" pitchFamily="34" charset="0"/>
+              <a:cs typeface="Segoe UI" panose="020B0502040204020203" pitchFamily="34" charset="0"/>
+            </a:endParaRPr>
+          </a:p>
+        </p:txBody>
+      </p:sp>
+      <p:sp>
+        <p:nvSpPr>
+          <p:cNvPr id="52" name="テキスト ボックス 51">
+            <a:extLst>
+              <a:ext uri="{FF2B5EF4-FFF2-40B4-BE49-F238E27FC236}">
+                <a16:creationId xmlns:a16="http://schemas.microsoft.com/office/drawing/2014/main" id="{6DB9852C-2C34-9F38-9871-A1FF2D15ED03}"/>
+              </a:ext>
+            </a:extLst>
+          </p:cNvPr>
+          <p:cNvSpPr txBox="1"/>
+          <p:nvPr/>
+        </p:nvSpPr>
+        <p:spPr>
+          <a:xfrm>
+            <a:off x="5587544" y="6266277"/>
+            <a:ext cx="1312396" cy="430887"/>
+          </a:xfrm>
+          <a:prstGeom prst="rect">
+            <a:avLst/>
+          </a:prstGeom>
+          <a:noFill/>
+        </p:spPr>
+        <p:txBody>
+          <a:bodyPr wrap="square" rtlCol="0">
+            <a:spAutoFit/>
+          </a:bodyPr>
+          <a:lstStyle/>
+          <a:p>
+            <a:pPr algn="ctr"/>
+            <a:r>
+              <a:rPr lang="en-US" altLang="ja-JP" sz="1100" dirty="0">
+                <a:latin typeface="Segoe UI" panose="020B0502040204020203" pitchFamily="34" charset="0"/>
+                <a:cs typeface="Segoe UI" panose="020B0502040204020203" pitchFamily="34" charset="0"/>
+              </a:rPr>
+              <a:t>Availability Zone</a:t>
+            </a:r>
+            <a:r>
+              <a:rPr kumimoji="1" lang="en-US" altLang="ja-JP" sz="1100" dirty="0">
+                <a:latin typeface="Segoe UI" panose="020B0502040204020203" pitchFamily="34" charset="0"/>
+                <a:cs typeface="Segoe UI" panose="020B0502040204020203" pitchFamily="34" charset="0"/>
+              </a:rPr>
+              <a:t> </a:t>
+            </a:r>
+          </a:p>
+          <a:p>
+            <a:pPr algn="ctr"/>
+            <a:r>
+              <a:rPr lang="en-US" altLang="ja-JP" sz="1100" dirty="0">
+                <a:latin typeface="Segoe UI" panose="020B0502040204020203" pitchFamily="34" charset="0"/>
+                <a:cs typeface="Segoe UI" panose="020B0502040204020203" pitchFamily="34" charset="0"/>
+              </a:rPr>
+              <a:t>3</a:t>
+            </a:r>
+            <a:endParaRPr kumimoji="1" lang="ja-JP" altLang="en-US" sz="1100">
+              <a:latin typeface="Segoe UI" panose="020B0502040204020203" pitchFamily="34" charset="0"/>
+              <a:cs typeface="Segoe UI" panose="020B0502040204020203" pitchFamily="34" charset="0"/>
+            </a:endParaRPr>
+          </a:p>
+        </p:txBody>
+      </p:sp>
+      <mc:AlternateContent xmlns:mc="http://schemas.openxmlformats.org/markup-compatibility/2006" xmlns:p14="http://schemas.microsoft.com/office/powerpoint/2010/main">
+        <mc:Choice Requires="p14">
+          <p:contentPart p14:bwMode="auto" r:id="rId40">
+            <p14:nvContentPartPr>
+              <p14:cNvPr id="61" name="インク 60">
+                <a:extLst>
+                  <a:ext uri="{FF2B5EF4-FFF2-40B4-BE49-F238E27FC236}">
+                    <a16:creationId xmlns:a16="http://schemas.microsoft.com/office/drawing/2014/main" id="{BFE2C54A-3049-D221-F8D8-4D89ED8063B3}"/>
+                  </a:ext>
+                </a:extLst>
+              </p14:cNvPr>
+              <p14:cNvContentPartPr/>
+              <p14:nvPr/>
+            </p14:nvContentPartPr>
+            <p14:xfrm>
+              <a:off x="3455394" y="840460"/>
+              <a:ext cx="312120" cy="1148040"/>
+            </p14:xfrm>
+          </p:contentPart>
+        </mc:Choice>
+        <mc:Fallback xmlns="">
+          <p:pic>
+            <p:nvPicPr>
+              <p:cNvPr id="61" name="インク 60">
+                <a:extLst>
+                  <a:ext uri="{FF2B5EF4-FFF2-40B4-BE49-F238E27FC236}">
+                    <a16:creationId xmlns:a16="http://schemas.microsoft.com/office/drawing/2014/main" id="{BFE2C54A-3049-D221-F8D8-4D89ED8063B3}"/>
+                  </a:ext>
+                </a:extLst>
+              </p:cNvPr>
+              <p:cNvPicPr/>
+              <p:nvPr/>
+            </p:nvPicPr>
+            <p:blipFill>
+              <a:blip r:embed="rId53"/>
+              <a:stretch>
+                <a:fillRect/>
+              </a:stretch>
+            </p:blipFill>
+            <p:spPr>
+              <a:xfrm>
+                <a:off x="3449274" y="834340"/>
+                <a:ext cx="324360" cy="1160280"/>
+              </a:xfrm>
+              <a:prstGeom prst="rect">
+                <a:avLst/>
+              </a:prstGeom>
+            </p:spPr>
+          </p:pic>
+        </mc:Fallback>
+      </mc:AlternateContent>
       <p:grpSp>
         <p:nvGrpSpPr>
-          <p:cNvPr id="111" name="グループ化 110">
-            <a:extLst>
-              <a:ext uri="{FF2B5EF4-FFF2-40B4-BE49-F238E27FC236}">
-                <a16:creationId xmlns:a16="http://schemas.microsoft.com/office/drawing/2014/main" id="{9FC4619E-7BD4-613F-4D4D-9CC9F844B8AB}"/>
+          <p:cNvPr id="95" name="グループ化 94">
+            <a:extLst>
+              <a:ext uri="{FF2B5EF4-FFF2-40B4-BE49-F238E27FC236}">
+                <a16:creationId xmlns:a16="http://schemas.microsoft.com/office/drawing/2014/main" id="{33ABB41D-3959-F9B6-4134-E4663DCC3208}"/>
               </a:ext>
             </a:extLst>
           </p:cNvPr>
@@ -7330,20 +7661,20 @@
         </p:nvGrpSpPr>
         <p:grpSpPr>
           <a:xfrm>
-            <a:off x="6411531" y="2292291"/>
-            <a:ext cx="1302120" cy="3066480"/>
-            <a:chOff x="6411531" y="2292291"/>
-            <a:chExt cx="1302120" cy="3066480"/>
+            <a:off x="4794193" y="2268551"/>
+            <a:ext cx="2861640" cy="1922760"/>
+            <a:chOff x="4794193" y="2268551"/>
+            <a:chExt cx="2861640" cy="1922760"/>
           </a:xfrm>
         </p:grpSpPr>
-        <mc:AlternateContent xmlns:mc="http://schemas.openxmlformats.org/markup-compatibility/2006" xmlns:p14="http://schemas.microsoft.com/office/powerpoint/2010/main">
-          <mc:Choice Requires="p14">
-            <p:contentPart p14:bwMode="auto" r:id="rId40">
+        <mc:AlternateContent xmlns:mc="http://schemas.openxmlformats.org/markup-compatibility/2006">
+          <mc:Choice xmlns:p14="http://schemas.microsoft.com/office/powerpoint/2010/main" Requires="p14">
+            <p:contentPart p14:bwMode="auto" r:id="rId54">
               <p14:nvContentPartPr>
-                <p14:cNvPr id="93" name="インク 92">
+                <p14:cNvPr id="64" name="インク 63">
                   <a:extLst>
                     <a:ext uri="{FF2B5EF4-FFF2-40B4-BE49-F238E27FC236}">
-                      <a16:creationId xmlns:a16="http://schemas.microsoft.com/office/drawing/2014/main" id="{9C6D82E2-4263-FE62-C78D-2F886FA17D3D}"/>
+                      <a16:creationId xmlns:a16="http://schemas.microsoft.com/office/drawing/2014/main" id="{026E97D6-B6DA-113F-CC56-C2D516EB8802}"/>
                     </a:ext>
                   </a:extLst>
                 </p14:cNvPr>
@@ -7351,18 +7682,18 @@
                 <p14:nvPr/>
               </p14:nvContentPartPr>
               <p14:xfrm>
-                <a:off x="6419091" y="2292291"/>
-                <a:ext cx="1294560" cy="868320"/>
+                <a:off x="4884913" y="2268551"/>
+                <a:ext cx="2770920" cy="847800"/>
               </p14:xfrm>
             </p:contentPart>
           </mc:Choice>
-          <mc:Fallback xmlns="">
+          <mc:Fallback>
             <p:pic>
               <p:nvPicPr>
-                <p:cNvPr id="93" name="インク 92">
+                <p:cNvPr id="64" name="インク 63">
                   <a:extLst>
                     <a:ext uri="{FF2B5EF4-FFF2-40B4-BE49-F238E27FC236}">
-                      <a16:creationId xmlns:a16="http://schemas.microsoft.com/office/drawing/2014/main" id="{9C6D82E2-4263-FE62-C78D-2F886FA17D3D}"/>
+                      <a16:creationId xmlns:a16="http://schemas.microsoft.com/office/drawing/2014/main" id="{026E97D6-B6DA-113F-CC56-C2D516EB8802}"/>
                     </a:ext>
                   </a:extLst>
                 </p:cNvPr>
@@ -7370,15 +7701,15 @@
                 <p:nvPr/>
               </p:nvPicPr>
               <p:blipFill>
-                <a:blip r:embed="rId41"/>
+                <a:blip r:embed="rId55"/>
                 <a:stretch>
                   <a:fillRect/>
                 </a:stretch>
               </p:blipFill>
               <p:spPr>
                 <a:xfrm>
-                  <a:off x="6412971" y="2286171"/>
-                  <a:ext cx="1306800" cy="880560"/>
+                  <a:off x="4878793" y="2262431"/>
+                  <a:ext cx="2783160" cy="860040"/>
                 </a:xfrm>
                 <a:prstGeom prst="rect">
                   <a:avLst/>
@@ -7387,14 +7718,14 @@
             </p:pic>
           </mc:Fallback>
         </mc:AlternateContent>
-        <mc:AlternateContent xmlns:mc="http://schemas.openxmlformats.org/markup-compatibility/2006" xmlns:p14="http://schemas.microsoft.com/office/powerpoint/2010/main">
-          <mc:Choice Requires="p14">
-            <p:contentPart p14:bwMode="auto" r:id="rId42">
+        <mc:AlternateContent xmlns:mc="http://schemas.openxmlformats.org/markup-compatibility/2006">
+          <mc:Choice xmlns:p14="http://schemas.microsoft.com/office/powerpoint/2010/main" Requires="p14">
+            <p:contentPart p14:bwMode="auto" r:id="rId56">
               <p14:nvContentPartPr>
-                <p14:cNvPr id="96" name="インク 95">
+                <p14:cNvPr id="66" name="インク 65">
                   <a:extLst>
                     <a:ext uri="{FF2B5EF4-FFF2-40B4-BE49-F238E27FC236}">
-                      <a16:creationId xmlns:a16="http://schemas.microsoft.com/office/drawing/2014/main" id="{B66950F6-EFCA-3E83-41B3-E619ED5C3F95}"/>
+                      <a16:creationId xmlns:a16="http://schemas.microsoft.com/office/drawing/2014/main" id="{C6817757-9D47-82EF-0698-E4E02B333BBE}"/>
                     </a:ext>
                   </a:extLst>
                 </p14:cNvPr>
@@ -7402,18 +7733,18 @@
                 <p14:nvPr/>
               </p14:nvContentPartPr>
               <p14:xfrm>
-                <a:off x="6411531" y="3025251"/>
-                <a:ext cx="111600" cy="180720"/>
+                <a:off x="4794553" y="3028871"/>
+                <a:ext cx="148320" cy="149400"/>
               </p14:xfrm>
             </p:contentPart>
           </mc:Choice>
-          <mc:Fallback xmlns="">
+          <mc:Fallback>
             <p:pic>
               <p:nvPicPr>
-                <p:cNvPr id="96" name="インク 95">
+                <p:cNvPr id="66" name="インク 65">
                   <a:extLst>
                     <a:ext uri="{FF2B5EF4-FFF2-40B4-BE49-F238E27FC236}">
-                      <a16:creationId xmlns:a16="http://schemas.microsoft.com/office/drawing/2014/main" id="{B66950F6-EFCA-3E83-41B3-E619ED5C3F95}"/>
+                      <a16:creationId xmlns:a16="http://schemas.microsoft.com/office/drawing/2014/main" id="{C6817757-9D47-82EF-0698-E4E02B333BBE}"/>
                     </a:ext>
                   </a:extLst>
                 </p:cNvPr>
@@ -7421,15 +7752,15 @@
                 <p:nvPr/>
               </p:nvPicPr>
               <p:blipFill>
-                <a:blip r:embed="rId43"/>
+                <a:blip r:embed="rId57"/>
                 <a:stretch>
                   <a:fillRect/>
                 </a:stretch>
               </p:blipFill>
               <p:spPr>
                 <a:xfrm>
-                  <a:off x="6405411" y="3019131"/>
-                  <a:ext cx="123840" cy="192960"/>
+                  <a:off x="4788433" y="3022751"/>
+                  <a:ext cx="160560" cy="161640"/>
                 </a:xfrm>
                 <a:prstGeom prst="rect">
                   <a:avLst/>
@@ -7438,14 +7769,14 @@
             </p:pic>
           </mc:Fallback>
         </mc:AlternateContent>
-        <mc:AlternateContent xmlns:mc="http://schemas.openxmlformats.org/markup-compatibility/2006" xmlns:p14="http://schemas.microsoft.com/office/powerpoint/2010/main">
-          <mc:Choice Requires="p14">
-            <p:contentPart p14:bwMode="auto" r:id="rId44">
+        <mc:AlternateContent xmlns:mc="http://schemas.openxmlformats.org/markup-compatibility/2006">
+          <mc:Choice xmlns:p14="http://schemas.microsoft.com/office/powerpoint/2010/main" Requires="p14">
+            <p:contentPart p14:bwMode="auto" r:id="rId58">
               <p14:nvContentPartPr>
-                <p14:cNvPr id="99" name="インク 98">
+                <p14:cNvPr id="76" name="インク 75">
                   <a:extLst>
                     <a:ext uri="{FF2B5EF4-FFF2-40B4-BE49-F238E27FC236}">
-                      <a16:creationId xmlns:a16="http://schemas.microsoft.com/office/drawing/2014/main" id="{8015BF0A-ADD9-957B-7404-C3B5A23FE22E}"/>
+                      <a16:creationId xmlns:a16="http://schemas.microsoft.com/office/drawing/2014/main" id="{01B413A9-0224-5E76-8D34-A9ACE0ADA05B}"/>
                     </a:ext>
                   </a:extLst>
                 </p14:cNvPr>
@@ -7453,18 +7784,18 @@
                 <p14:nvPr/>
               </p14:nvContentPartPr>
               <p14:xfrm>
-                <a:off x="6590091" y="2452851"/>
-                <a:ext cx="824040" cy="1715760"/>
+                <a:off x="4875913" y="2739431"/>
+                <a:ext cx="1705680" cy="1430640"/>
               </p14:xfrm>
             </p:contentPart>
           </mc:Choice>
-          <mc:Fallback xmlns="">
+          <mc:Fallback>
             <p:pic>
               <p:nvPicPr>
-                <p:cNvPr id="99" name="インク 98">
+                <p:cNvPr id="76" name="インク 75">
                   <a:extLst>
                     <a:ext uri="{FF2B5EF4-FFF2-40B4-BE49-F238E27FC236}">
-                      <a16:creationId xmlns:a16="http://schemas.microsoft.com/office/drawing/2014/main" id="{8015BF0A-ADD9-957B-7404-C3B5A23FE22E}"/>
+                      <a16:creationId xmlns:a16="http://schemas.microsoft.com/office/drawing/2014/main" id="{01B413A9-0224-5E76-8D34-A9ACE0ADA05B}"/>
                     </a:ext>
                   </a:extLst>
                 </p:cNvPr>
@@ -7472,15 +7803,15 @@
                 <p:nvPr/>
               </p:nvPicPr>
               <p:blipFill>
-                <a:blip r:embed="rId45"/>
+                <a:blip r:embed="rId59"/>
                 <a:stretch>
                   <a:fillRect/>
                 </a:stretch>
               </p:blipFill>
               <p:spPr>
                 <a:xfrm>
-                  <a:off x="6583971" y="2446731"/>
-                  <a:ext cx="836280" cy="1728000"/>
+                  <a:off x="4869793" y="2733311"/>
+                  <a:ext cx="1717920" cy="1442880"/>
                 </a:xfrm>
                 <a:prstGeom prst="rect">
                   <a:avLst/>
@@ -7489,14 +7820,14 @@
             </p:pic>
           </mc:Fallback>
         </mc:AlternateContent>
-        <mc:AlternateContent xmlns:mc="http://schemas.openxmlformats.org/markup-compatibility/2006" xmlns:p14="http://schemas.microsoft.com/office/powerpoint/2010/main">
-          <mc:Choice Requires="p14">
-            <p:contentPart p14:bwMode="auto" r:id="rId46">
+        <mc:AlternateContent xmlns:mc="http://schemas.openxmlformats.org/markup-compatibility/2006">
+          <mc:Choice xmlns:p14="http://schemas.microsoft.com/office/powerpoint/2010/main" Requires="p14">
+            <p:contentPart p14:bwMode="auto" r:id="rId60">
               <p14:nvContentPartPr>
-                <p14:cNvPr id="105" name="インク 104">
+                <p14:cNvPr id="89" name="インク 88">
                   <a:extLst>
                     <a:ext uri="{FF2B5EF4-FFF2-40B4-BE49-F238E27FC236}">
-                      <a16:creationId xmlns:a16="http://schemas.microsoft.com/office/drawing/2014/main" id="{39CAD90E-A6C2-0D08-D1B2-2600A7518A70}"/>
+                      <a16:creationId xmlns:a16="http://schemas.microsoft.com/office/drawing/2014/main" id="{9C51420E-4F71-3A9E-C02B-24CF12A089DF}"/>
                     </a:ext>
                   </a:extLst>
                 </p14:cNvPr>
@@ -7504,18 +7835,18 @@
                 <p14:nvPr/>
               </p14:nvContentPartPr>
               <p14:xfrm>
-                <a:off x="6482811" y="3990411"/>
-                <a:ext cx="254880" cy="271080"/>
+                <a:off x="4794193" y="4086551"/>
+                <a:ext cx="150480" cy="104760"/>
               </p14:xfrm>
             </p:contentPart>
           </mc:Choice>
-          <mc:Fallback xmlns="">
+          <mc:Fallback>
             <p:pic>
               <p:nvPicPr>
-                <p:cNvPr id="105" name="インク 104">
+                <p:cNvPr id="89" name="インク 88">
                   <a:extLst>
                     <a:ext uri="{FF2B5EF4-FFF2-40B4-BE49-F238E27FC236}">
-                      <a16:creationId xmlns:a16="http://schemas.microsoft.com/office/drawing/2014/main" id="{39CAD90E-A6C2-0D08-D1B2-2600A7518A70}"/>
+                      <a16:creationId xmlns:a16="http://schemas.microsoft.com/office/drawing/2014/main" id="{9C51420E-4F71-3A9E-C02B-24CF12A089DF}"/>
                     </a:ext>
                   </a:extLst>
                 </p:cNvPr>
@@ -7523,117 +7854,15 @@
                 <p:nvPr/>
               </p:nvPicPr>
               <p:blipFill>
-                <a:blip r:embed="rId47"/>
+                <a:blip r:embed="rId61"/>
                 <a:stretch>
                   <a:fillRect/>
                 </a:stretch>
               </p:blipFill>
               <p:spPr>
                 <a:xfrm>
-                  <a:off x="6476691" y="3984291"/>
-                  <a:ext cx="267120" cy="283320"/>
-                </a:xfrm>
-                <a:prstGeom prst="rect">
-                  <a:avLst/>
-                </a:prstGeom>
-              </p:spPr>
-            </p:pic>
-          </mc:Fallback>
-        </mc:AlternateContent>
-        <mc:AlternateContent xmlns:mc="http://schemas.openxmlformats.org/markup-compatibility/2006" xmlns:p14="http://schemas.microsoft.com/office/powerpoint/2010/main">
-          <mc:Choice Requires="p14">
-            <p:contentPart p14:bwMode="auto" r:id="rId48">
-              <p14:nvContentPartPr>
-                <p14:cNvPr id="106" name="インク 105">
-                  <a:extLst>
-                    <a:ext uri="{FF2B5EF4-FFF2-40B4-BE49-F238E27FC236}">
-                      <a16:creationId xmlns:a16="http://schemas.microsoft.com/office/drawing/2014/main" id="{38ACE402-E392-7B47-FE66-3E48BB3675B6}"/>
-                    </a:ext>
-                  </a:extLst>
-                </p14:cNvPr>
-                <p14:cNvContentPartPr/>
-                <p14:nvPr/>
-              </p14:nvContentPartPr>
-              <p14:xfrm>
-                <a:off x="6589371" y="3521691"/>
-                <a:ext cx="875160" cy="1737720"/>
-              </p14:xfrm>
-            </p:contentPart>
-          </mc:Choice>
-          <mc:Fallback xmlns="">
-            <p:pic>
-              <p:nvPicPr>
-                <p:cNvPr id="106" name="インク 105">
-                  <a:extLst>
-                    <a:ext uri="{FF2B5EF4-FFF2-40B4-BE49-F238E27FC236}">
-                      <a16:creationId xmlns:a16="http://schemas.microsoft.com/office/drawing/2014/main" id="{38ACE402-E392-7B47-FE66-3E48BB3675B6}"/>
-                    </a:ext>
-                  </a:extLst>
-                </p:cNvPr>
-                <p:cNvPicPr/>
-                <p:nvPr/>
-              </p:nvPicPr>
-              <p:blipFill>
-                <a:blip r:embed="rId49"/>
-                <a:stretch>
-                  <a:fillRect/>
-                </a:stretch>
-              </p:blipFill>
-              <p:spPr>
-                <a:xfrm>
-                  <a:off x="6583251" y="3515571"/>
-                  <a:ext cx="887400" cy="1749960"/>
-                </a:xfrm>
-                <a:prstGeom prst="rect">
-                  <a:avLst/>
-                </a:prstGeom>
-              </p:spPr>
-            </p:pic>
-          </mc:Fallback>
-        </mc:AlternateContent>
-        <mc:AlternateContent xmlns:mc="http://schemas.openxmlformats.org/markup-compatibility/2006" xmlns:p14="http://schemas.microsoft.com/office/powerpoint/2010/main">
-          <mc:Choice Requires="p14">
-            <p:contentPart p14:bwMode="auto" r:id="rId50">
-              <p14:nvContentPartPr>
-                <p14:cNvPr id="109" name="インク 108">
-                  <a:extLst>
-                    <a:ext uri="{FF2B5EF4-FFF2-40B4-BE49-F238E27FC236}">
-                      <a16:creationId xmlns:a16="http://schemas.microsoft.com/office/drawing/2014/main" id="{93FE5A21-994E-8FBB-F9B7-98C5B6212611}"/>
-                    </a:ext>
-                  </a:extLst>
-                </p14:cNvPr>
-                <p14:cNvContentPartPr/>
-                <p14:nvPr/>
-              </p14:nvContentPartPr>
-              <p14:xfrm>
-                <a:off x="6428451" y="5186691"/>
-                <a:ext cx="240480" cy="172080"/>
-              </p14:xfrm>
-            </p:contentPart>
-          </mc:Choice>
-          <mc:Fallback xmlns="">
-            <p:pic>
-              <p:nvPicPr>
-                <p:cNvPr id="109" name="インク 108">
-                  <a:extLst>
-                    <a:ext uri="{FF2B5EF4-FFF2-40B4-BE49-F238E27FC236}">
-                      <a16:creationId xmlns:a16="http://schemas.microsoft.com/office/drawing/2014/main" id="{93FE5A21-994E-8FBB-F9B7-98C5B6212611}"/>
-                    </a:ext>
-                  </a:extLst>
-                </p:cNvPr>
-                <p:cNvPicPr/>
-                <p:nvPr/>
-              </p:nvPicPr>
-              <p:blipFill>
-                <a:blip r:embed="rId51"/>
-                <a:stretch>
-                  <a:fillRect/>
-                </a:stretch>
-              </p:blipFill>
-              <p:spPr>
-                <a:xfrm>
-                  <a:off x="6422331" y="5180571"/>
-                  <a:ext cx="252720" cy="184320"/>
+                  <a:off x="4788073" y="4080431"/>
+                  <a:ext cx="162720" cy="117000"/>
                 </a:xfrm>
                 <a:prstGeom prst="rect">
                   <a:avLst/>
@@ -7643,54 +7872,129 @@
           </mc:Fallback>
         </mc:AlternateContent>
       </p:grpSp>
-      <p:sp>
-        <p:nvSpPr>
-          <p:cNvPr id="112" name="テキスト ボックス 111">
-            <a:extLst>
-              <a:ext uri="{FF2B5EF4-FFF2-40B4-BE49-F238E27FC236}">
-                <a16:creationId xmlns:a16="http://schemas.microsoft.com/office/drawing/2014/main" id="{C1F7DE73-C89B-A3B3-55F9-3B74659430A4}"/>
-              </a:ext>
-            </a:extLst>
-          </p:cNvPr>
-          <p:cNvSpPr txBox="1"/>
+      <p:grpSp>
+        <p:nvGrpSpPr>
+          <p:cNvPr id="101" name="グループ化 100">
+            <a:extLst>
+              <a:ext uri="{FF2B5EF4-FFF2-40B4-BE49-F238E27FC236}">
+                <a16:creationId xmlns:a16="http://schemas.microsoft.com/office/drawing/2014/main" id="{9D1BD9E1-72AD-25F6-4591-327EBE371B4A}"/>
+              </a:ext>
+            </a:extLst>
+          </p:cNvPr>
+          <p:cNvGrpSpPr/>
           <p:nvPr/>
-        </p:nvSpPr>
-        <p:spPr>
-          <a:xfrm>
-            <a:off x="6926569" y="1397411"/>
-            <a:ext cx="1726345" cy="430887"/>
-          </a:xfrm>
-          <a:prstGeom prst="rect">
-            <a:avLst/>
-          </a:prstGeom>
-          <a:noFill/>
-        </p:spPr>
-        <p:txBody>
-          <a:bodyPr wrap="square" rtlCol="0">
-            <a:spAutoFit/>
-          </a:bodyPr>
-          <a:lstStyle/>
-          <a:p>
-            <a:r>
-              <a:rPr lang="en-US" altLang="ja-JP" sz="1100" dirty="0">
-                <a:solidFill>
-                  <a:srgbClr val="FF0000"/>
-                </a:solidFill>
-                <a:latin typeface="Segoe UI" panose="020B0502040204020203" pitchFamily="34" charset="0"/>
-                <a:cs typeface="Segoe UI" panose="020B0502040204020203" pitchFamily="34" charset="0"/>
-              </a:rPr>
-              <a:t>Configure VMs and implement applications</a:t>
-            </a:r>
-            <a:endParaRPr kumimoji="1" lang="ja-JP" altLang="en-US" sz="1100">
-              <a:solidFill>
-                <a:srgbClr val="FF0000"/>
-              </a:solidFill>
-              <a:latin typeface="Segoe UI" panose="020B0502040204020203" pitchFamily="34" charset="0"/>
-              <a:cs typeface="Segoe UI" panose="020B0502040204020203" pitchFamily="34" charset="0"/>
-            </a:endParaRPr>
-          </a:p>
-        </p:txBody>
-      </p:sp>
+        </p:nvGrpSpPr>
+        <p:grpSpPr>
+          <a:xfrm>
+            <a:off x="5974993" y="3921311"/>
+            <a:ext cx="496440" cy="1271880"/>
+            <a:chOff x="5974993" y="3921311"/>
+            <a:chExt cx="496440" cy="1271880"/>
+          </a:xfrm>
+        </p:grpSpPr>
+        <mc:AlternateContent xmlns:mc="http://schemas.openxmlformats.org/markup-compatibility/2006">
+          <mc:Choice xmlns:p14="http://schemas.microsoft.com/office/powerpoint/2010/main" Requires="p14">
+            <p:contentPart p14:bwMode="auto" r:id="rId62">
+              <p14:nvContentPartPr>
+                <p14:cNvPr id="97" name="インク 96">
+                  <a:extLst>
+                    <a:ext uri="{FF2B5EF4-FFF2-40B4-BE49-F238E27FC236}">
+                      <a16:creationId xmlns:a16="http://schemas.microsoft.com/office/drawing/2014/main" id="{B5ABA8AF-01D5-0516-196B-C6E82283EA22}"/>
+                    </a:ext>
+                  </a:extLst>
+                </p14:cNvPr>
+                <p14:cNvContentPartPr/>
+                <p14:nvPr/>
+              </p14:nvContentPartPr>
+              <p14:xfrm>
+                <a:off x="6009913" y="3921311"/>
+                <a:ext cx="461520" cy="1223280"/>
+              </p14:xfrm>
+            </p:contentPart>
+          </mc:Choice>
+          <mc:Fallback>
+            <p:pic>
+              <p:nvPicPr>
+                <p:cNvPr id="97" name="インク 96">
+                  <a:extLst>
+                    <a:ext uri="{FF2B5EF4-FFF2-40B4-BE49-F238E27FC236}">
+                      <a16:creationId xmlns:a16="http://schemas.microsoft.com/office/drawing/2014/main" id="{B5ABA8AF-01D5-0516-196B-C6E82283EA22}"/>
+                    </a:ext>
+                  </a:extLst>
+                </p:cNvPr>
+                <p:cNvPicPr/>
+                <p:nvPr/>
+              </p:nvPicPr>
+              <p:blipFill>
+                <a:blip r:embed="rId63"/>
+                <a:stretch>
+                  <a:fillRect/>
+                </a:stretch>
+              </p:blipFill>
+              <p:spPr>
+                <a:xfrm>
+                  <a:off x="6003793" y="3915191"/>
+                  <a:ext cx="473760" cy="1235520"/>
+                </a:xfrm>
+                <a:prstGeom prst="rect">
+                  <a:avLst/>
+                </a:prstGeom>
+              </p:spPr>
+            </p:pic>
+          </mc:Fallback>
+        </mc:AlternateContent>
+        <mc:AlternateContent xmlns:mc="http://schemas.openxmlformats.org/markup-compatibility/2006">
+          <mc:Choice xmlns:p14="http://schemas.microsoft.com/office/powerpoint/2010/main" Requires="p14">
+            <p:contentPart p14:bwMode="auto" r:id="rId64">
+              <p14:nvContentPartPr>
+                <p14:cNvPr id="98" name="インク 97">
+                  <a:extLst>
+                    <a:ext uri="{FF2B5EF4-FFF2-40B4-BE49-F238E27FC236}">
+                      <a16:creationId xmlns:a16="http://schemas.microsoft.com/office/drawing/2014/main" id="{9B24D881-1844-7B11-8084-BF5041C25A85}"/>
+                    </a:ext>
+                  </a:extLst>
+                </p14:cNvPr>
+                <p14:cNvContentPartPr/>
+                <p14:nvPr/>
+              </p14:nvContentPartPr>
+              <p14:xfrm>
+                <a:off x="5974993" y="5050631"/>
+                <a:ext cx="255240" cy="142560"/>
+              </p14:xfrm>
+            </p:contentPart>
+          </mc:Choice>
+          <mc:Fallback>
+            <p:pic>
+              <p:nvPicPr>
+                <p:cNvPr id="98" name="インク 97">
+                  <a:extLst>
+                    <a:ext uri="{FF2B5EF4-FFF2-40B4-BE49-F238E27FC236}">
+                      <a16:creationId xmlns:a16="http://schemas.microsoft.com/office/drawing/2014/main" id="{9B24D881-1844-7B11-8084-BF5041C25A85}"/>
+                    </a:ext>
+                  </a:extLst>
+                </p:cNvPr>
+                <p:cNvPicPr/>
+                <p:nvPr/>
+              </p:nvPicPr>
+              <p:blipFill>
+                <a:blip r:embed="rId65"/>
+                <a:stretch>
+                  <a:fillRect/>
+                </a:stretch>
+              </p:blipFill>
+              <p:spPr>
+                <a:xfrm>
+                  <a:off x="5968873" y="5044511"/>
+                  <a:ext cx="267480" cy="154800"/>
+                </a:xfrm>
+                <a:prstGeom prst="rect">
+                  <a:avLst/>
+                </a:prstGeom>
+              </p:spPr>
+            </p:pic>
+          </mc:Fallback>
+        </mc:AlternateContent>
+      </p:grpSp>
     </p:spTree>
     <p:extLst>
       <p:ext uri="{BB962C8B-B14F-4D97-AF65-F5344CB8AC3E}">

</xml_diff>